<commit_message>
Placas de la VSL con colores y tipografías de marca
Co-Authored-By: Claude Opus 5.5 <noreply@anthropic.com>
Claude-Session: https://claude.ai/code/session_01CaLehPNPrEp7xKjDjXwurb
</commit_message>
<xml_diff>
--- a/contenido/vsl/Placas_VSL_AT_WORK_@breakingbarriers.atwork.pptx
+++ b/contenido/vsl/Placas_VSL_AT_WORK_@breakingbarriers.atwork.pptx
@@ -134,18 +134,18 @@
   <p:extLst>
     <p:ext uri="{521415D9-36F7-43E2-AB2F-B90AF26B5E84}">
       <p14:sectionLst xmlns:p14="http://schemas.microsoft.com/office/powerpoint/2010/main">
-        <p14:section name="Portada" id="{9389b4bf-1c12-9789-3bfe-1c95f5324e03}">
+        <p14:section name="Portada" id="{f7747519-c6e2-b96c-0a9a-ea8389658bfa}">
           <p14:sldIdLst>
             <p14:sldId id="256"/>
           </p14:sldIdLst>
         </p14:section>
-        <p14:section name="1–2 · Opening y para quién" id="{7764f333-93b5-d5fc-c01f-218f2c0e26cd}">
+        <p14:section name="1–2 · Opening y para quién" id="{f3b376d9-722d-780a-b3ac-94cdaa06a36e}">
           <p14:sldIdLst>
             <p14:sldId id="257"/>
             <p14:sldId id="258"/>
           </p14:sldIdLst>
         </p14:section>
-        <p14:section name="3 · Alumnas" id="{87bf89b7-5916-a4ed-4455-83113425e00a}">
+        <p14:section name="3 · Alumnas" id="{fbb0e4ce-0e08-82b9-cc26-ea66818eb9d8}">
           <p14:sldIdLst>
             <p14:sldId id="259"/>
             <p14:sldId id="260"/>
@@ -155,7 +155,7 @@
             <p14:sldId id="264"/>
           </p14:sldIdLst>
         </p14:section>
-        <p14:section name="4–6 · Idea central" id="{4e8b5e82-c75e-e59a-47da-ebf4aca44e82}">
+        <p14:section name="4–6 · Idea central" id="{248625dc-c64e-0991-6621-337deac5c010}">
           <p14:sldIdLst>
             <p14:sldId id="265"/>
             <p14:sldId id="266"/>
@@ -163,13 +163,13 @@
             <p14:sldId id="268"/>
           </p14:sldIdLst>
         </p14:section>
-        <p14:section name="7–8 · Qué cambiamos" id="{37e5c6f2-a652-f3be-dada-e902c791fac4}">
+        <p14:section name="7–8 · Qué cambiamos" id="{6df40bc2-63ca-d0e1-d2f2-e065f440112a}">
           <p14:sldIdLst>
             <p14:sldId id="269"/>
             <p14:sldId id="270"/>
           </p14:sldIdLst>
         </p14:section>
-        <p14:section name="9 · Delivery Method" id="{51e9a3b3-78dd-8a0a-40be-735b4fd61fac}">
+        <p14:section name="9 · Delivery Method" id="{ff6892ac-a951-9e7f-e1d3-017d0c8be292}">
           <p14:sldIdLst>
             <p14:sldId id="271"/>
             <p14:sldId id="272"/>
@@ -180,7 +180,7 @@
             <p14:sldId id="277"/>
           </p14:sldIdLst>
         </p14:section>
-        <p14:section name="10–11 · Cierre y CTA" id="{34a29ef2-2706-e84f-8aac-25cbabb27c48}">
+        <p14:section name="10–11 · Cierre y CTA" id="{aa6a369e-6e47-9480-99de-7c92995afd36}">
           <p14:sldIdLst>
             <p14:sldId id="278"/>
             <p14:sldId id="279"/>
@@ -3044,11 +3044,11 @@
 
 <file path=ppt/slideLayouts/slideLayout2.xml><?xml version="1.0" encoding="utf-8"?>
 <p:sldLayout xmlns:a="http://schemas.openxmlformats.org/drawingml/2006/main" xmlns:r="http://schemas.openxmlformats.org/officeDocument/2006/relationships" xmlns:p="http://schemas.openxmlformats.org/presentationml/2006/main" preserve="1">
-  <p:cSld name="PLACA">
+  <p:cSld name="MARRON">
     <p:bg>
       <p:bgPr>
         <a:solidFill>
-          <a:schemeClr val="tx1"/>
+          <a:schemeClr val="tx2"/>
         </a:solidFill>
       </p:bgPr>
     </p:bg>
@@ -3126,7 +3126,7 @@
           <a:lstStyle>
             <a:lvl1pPr indent="0" marL="0">
               <a:buNone/>
-              <a:defRPr lang="en-US" sz="1600" b="1" spc="300" kern="0" dirty="0">
+              <a:defRPr lang="en-US" sz="1500" b="1" spc="300" kern="0" dirty="0">
                 <a:solidFill>
                   <a:schemeClr val="accent1"/>
                 </a:solidFill>
@@ -3137,7 +3137,7 @@
             <a:pPr indent="0" marL="0">
               <a:buNone/>
             </a:pPr>
-            <a:endParaRPr lang="en-US" sz="1600" dirty="0"/>
+            <a:endParaRPr lang="en-US" sz="1500" dirty="0"/>
           </a:p>
         </p:txBody>
       </p:sp>
@@ -3181,6 +3181,158 @@
             <a:fld id="{F7021451-1387-4CA6-816F-3879F97B5CBC}" type="slidenum">
               <a:rPr b="0" lang="en-US"/>
               <a:t>1002</a:t>
+            </a:fld>
+            <a:endParaRPr lang="en-US"/>
+          </a:p>
+        </p:txBody>
+      </p:sp>
+    </p:spTree>
+  </p:cSld>
+  <p:clrMapOvr>
+    <a:masterClrMapping/>
+  </p:clrMapOvr>
+</p:sldLayout>
+</file>
+
+<file path=ppt/slideLayouts/slideLayout3.xml><?xml version="1.0" encoding="utf-8"?>
+<p:sldLayout xmlns:a="http://schemas.openxmlformats.org/drawingml/2006/main" xmlns:r="http://schemas.openxmlformats.org/officeDocument/2006/relationships" xmlns:p="http://schemas.openxmlformats.org/presentationml/2006/main" preserve="1">
+  <p:cSld name="CREMA">
+    <p:bg>
+      <p:bgPr>
+        <a:solidFill>
+          <a:schemeClr val="bg1"/>
+        </a:solidFill>
+      </p:bgPr>
+    </p:bg>
+    <p:spTree>
+      <p:nvGrpSpPr>
+        <p:cNvPr id="1" name=""/>
+        <p:cNvGrpSpPr/>
+        <p:nvPr/>
+      </p:nvGrpSpPr>
+      <p:grpSpPr>
+        <a:xfrm>
+          <a:off x="0" y="0"/>
+          <a:ext cx="0" cy="0"/>
+          <a:chOff x="0" y="0"/>
+          <a:chExt cx="0" cy="0"/>
+        </a:xfrm>
+      </p:grpSpPr>
+      <p:sp>
+        <p:nvSpPr>
+          <p:cNvPr id="2" name="Text 0"/>
+          <p:cNvSpPr/>
+          <p:nvPr/>
+        </p:nvSpPr>
+        <p:spPr>
+          <a:xfrm>
+            <a:off x="731520" y="6217920"/>
+            <a:ext cx="5486400" cy="320040"/>
+          </a:xfrm>
+          <a:prstGeom prst="rect">
+            <a:avLst/>
+          </a:prstGeom>
+          <a:noFill/>
+          <a:ln/>
+        </p:spPr>
+        <p:txBody>
+          <a:bodyPr wrap="square" lIns="0" tIns="0" rIns="0" bIns="0" rtlCol="0" anchor="ctr"/>
+          <a:lstStyle/>
+          <a:p>
+            <a:pPr indent="0" marL="0">
+              <a:buNone/>
+            </a:pPr>
+            <a:r>
+              <a:rPr lang="en-US" sz="1100" spc="400" kern="0" dirty="0">
+                <a:solidFill>
+                  <a:schemeClr val="accent5"/>
+                </a:solidFill>
+              </a:rPr>
+              <a:t>BREAKING BARRIERS AT WORK</a:t>
+            </a:r>
+            <a:endParaRPr lang="en-US" sz="1100" dirty="0"/>
+          </a:p>
+        </p:txBody>
+      </p:sp>
+      <p:sp>
+        <p:nvSpPr>
+          <p:cNvPr id="3" name="Text 1"/>
+          <p:cNvSpPr/>
+          <p:nvPr>
+            <p:ph idx="101" type="body" hasCustomPrompt="1"/>
+          </p:nvPr>
+        </p:nvSpPr>
+        <p:spPr>
+          <a:xfrm>
+            <a:off x="731520" y="1097280"/>
+            <a:ext cx="10698480" cy="457200"/>
+          </a:xfrm>
+          <a:prstGeom prst="rect">
+            <a:avLst/>
+          </a:prstGeom>
+          <a:noFill/>
+          <a:ln/>
+        </p:spPr>
+        <p:txBody>
+          <a:bodyPr wrap="square" rtlCol="0"/>
+          <a:lstStyle>
+            <a:lvl1pPr indent="0" marL="0">
+              <a:buNone/>
+              <a:defRPr lang="en-US" sz="1500" b="1" spc="300" kern="0" dirty="0">
+                <a:solidFill>
+                  <a:schemeClr val="accent2"/>
+                </a:solidFill>
+              </a:defRPr>
+            </a:lvl1pPr>
+          </a:lstStyle>
+          <a:p>
+            <a:pPr indent="0" marL="0">
+              <a:buNone/>
+            </a:pPr>
+            <a:endParaRPr lang="en-US" sz="1500" dirty="0"/>
+          </a:p>
+        </p:txBody>
+      </p:sp>
+      <p:sp>
+        <p:nvSpPr>
+          <p:cNvPr id="25" name="Slide Number Placeholder 0"/>
+          <p:cNvSpPr>
+            <a:spLocks noGrp="1"/>
+          </p:cNvSpPr>
+          <p:nvPr>
+            <p:ph type="sldNum" sz="quarter" idx="4294967295"/>
+          </p:nvPr>
+        </p:nvSpPr>
+        <p:spPr>
+          <a:xfrm>
+            <a:off x="10972800" y="6217920"/>
+            <a:ext cx="548640" cy="320040"/>
+          </a:xfrm>
+          <a:prstGeom prst="rect">
+            <a:avLst/>
+          </a:prstGeom>
+          <a:extLst>
+            <a:ext uri="{C572A759-6A51-4108-AA02-DFA0A04FC94B}">
+              <ma14:wrappingTextBoxFlag xmlns:ma14="http://schemas.microsoft.com/office/mac/drawingml/2011/main" val="0"/>
+            </a:ext>
+          </a:extLst>
+        </p:spPr>
+        <p:txBody>
+          <a:bodyPr/>
+          <a:lstStyle>
+            <a:lvl1pPr>
+              <a:defRPr sz="1100">
+                <a:solidFill>
+                  <a:schemeClr val="accent5"/>
+                </a:solidFill>
+              </a:defRPr>
+            </a:lvl1pPr>
+          </a:lstStyle>
+          <a:p>
+            <a:pPr algn="r"/>
+            <a:fld id="{F7021451-1387-4CA6-816F-3879F97B5CBC}" type="slidenum">
+              <a:rPr b="0" lang="en-US"/>
+              <a:t>1003</a:t>
             </a:fld>
             <a:endParaRPr lang="en-US"/>
           </a:p>
@@ -3262,6 +3414,7 @@
   <p:sldLayoutIdLst>
     <p:sldLayoutId id="2147483649" r:id="rId1"/>
     <p:sldLayoutId id="2147483650" r:id="rId2"/>
+    <p:sldLayoutId id="2147483651" r:id="rId3"/>
   </p:sldLayoutIdLst>
   <p:hf sldNum="0" hdr="0" ftr="0" dt="0"/>
   <p:txStyles>
@@ -3561,14 +3714,14 @@
               <a:buNone/>
             </a:pPr>
             <a:r>
-              <a:rPr lang="en-US" sz="1600" b="1" spc="300" kern="0" dirty="0">
+              <a:rPr lang="en-US" sz="1500" b="1" spc="300" kern="0" dirty="0">
                 <a:solidFill>
                   <a:schemeClr val="accent1"/>
                 </a:solidFill>
               </a:rPr>
               <a:t>BREAKING BARRIERS AT WORK</a:t>
             </a:r>
-            <a:endParaRPr lang="en-US" sz="1600" dirty="0"/>
+            <a:endParaRPr lang="en-US" sz="1500" dirty="0"/>
           </a:p>
         </p:txBody>
       </p:sp>
@@ -3595,39 +3748,39 @@
           <a:p>
             <a:pPr indent="0" marL="0">
               <a:lnSpc>
-                <a:spcPct val="105000"/>
+                <a:spcPct val="100000"/>
               </a:lnSpc>
               <a:buNone/>
             </a:pPr>
             <a:r>
-              <a:rPr lang="en-US" sz="5600" b="1" dirty="0">
+              <a:rPr lang="en-US" sz="6400" b="1" dirty="0">
                 <a:solidFill>
                   <a:schemeClr val="bg1"/>
                 </a:solidFill>
-                <a:latin typeface="Cambria" pitchFamily="34" charset="0"/>
-                <a:ea typeface="Cambria" pitchFamily="34" charset="-122"/>
-                <a:cs typeface="Cambria" pitchFamily="34" charset="-120"/>
+                <a:latin typeface="Crimson Pro" pitchFamily="34" charset="0"/>
+                <a:ea typeface="Crimson Pro" pitchFamily="34" charset="-122"/>
+                <a:cs typeface="Crimson Pro" pitchFamily="34" charset="-120"/>
               </a:rPr>
               <a:t>Cómo mostrar en inglés a la profesional que </a:t>
             </a:r>
             <a:pPr indent="0" marL="0">
               <a:lnSpc>
-                <a:spcPct val="105000"/>
+                <a:spcPct val="100000"/>
               </a:lnSpc>
               <a:buNone/>
             </a:pPr>
             <a:r>
-              <a:rPr lang="en-US" sz="5600" b="1" dirty="0">
+              <a:rPr lang="en-US" sz="6400" b="1" i="1" dirty="0">
                 <a:solidFill>
                   <a:schemeClr val="accent1"/>
                 </a:solidFill>
-                <a:latin typeface="Cambria" pitchFamily="34" charset="0"/>
-                <a:ea typeface="Cambria" pitchFamily="34" charset="-122"/>
-                <a:cs typeface="Cambria" pitchFamily="34" charset="-120"/>
+                <a:latin typeface="Crimson Pro" pitchFamily="34" charset="0"/>
+                <a:ea typeface="Crimson Pro" pitchFamily="34" charset="-122"/>
+                <a:cs typeface="Crimson Pro" pitchFamily="34" charset="-120"/>
               </a:rPr>
               <a:t>ya sos</a:t>
             </a:r>
-            <a:endParaRPr lang="en-US" sz="5600" dirty="0"/>
+            <a:endParaRPr lang="en-US" sz="6400" dirty="0"/>
           </a:p>
         </p:txBody>
       </p:sp>
@@ -3639,7 +3792,7 @@
         </p:nvSpPr>
         <p:spPr>
           <a:xfrm>
-            <a:off x="731520" y="4297680"/>
+            <a:off x="731520" y="4206240"/>
             <a:ext cx="10058400" cy="914400"/>
           </a:xfrm>
           <a:prstGeom prst="rect">
@@ -3656,14 +3809,14 @@
               <a:buNone/>
             </a:pPr>
             <a:r>
-              <a:rPr lang="en-US" sz="2200" dirty="0">
+              <a:rPr lang="en-US" sz="2000" dirty="0">
                 <a:solidFill>
                   <a:schemeClr val="bg2"/>
                 </a:solidFill>
               </a:rPr>
               <a:t>Sin sumar más años de clases ni memorizar guiones.</a:t>
             </a:r>
-            <a:endParaRPr lang="en-US" sz="2200" dirty="0"/>
+            <a:endParaRPr lang="en-US" sz="2000" dirty="0"/>
           </a:p>
         </p:txBody>
       </p:sp>
@@ -3764,14 +3917,14 @@
               <a:buNone/>
             </a:pPr>
             <a:r>
-              <a:rPr lang="en-US" sz="1600" b="1" spc="300" kern="0" dirty="0">
+              <a:rPr lang="en-US" sz="1500" b="1" spc="300" kern="0" dirty="0">
                 <a:solidFill>
                   <a:schemeClr val="accent1"/>
                 </a:solidFill>
               </a:rPr>
               <a:t>4 · EL OBJETIVO</a:t>
             </a:r>
-            <a:endParaRPr lang="en-US" sz="1600" dirty="0"/>
+            <a:endParaRPr lang="en-US" sz="1500" dirty="0"/>
           </a:p>
         </p:txBody>
       </p:sp>
@@ -3783,8 +3936,8 @@
         </p:nvSpPr>
         <p:spPr>
           <a:xfrm>
-            <a:off x="731520" y="1920240"/>
-            <a:ext cx="10698480" cy="3108960"/>
+            <a:off x="731520" y="1828800"/>
+            <a:ext cx="10698480" cy="3291840"/>
           </a:xfrm>
           <a:prstGeom prst="rect">
             <a:avLst/>
@@ -3798,42 +3951,42 @@
           <a:p>
             <a:pPr algn="ctr" indent="0" marL="0">
               <a:lnSpc>
-                <a:spcPct val="105000"/>
+                <a:spcPct val="100000"/>
               </a:lnSpc>
               <a:buNone/>
             </a:pPr>
             <a:r>
-              <a:rPr lang="en-US" sz="8800" b="1" dirty="0">
+              <a:rPr lang="en-US" sz="10000" b="1" dirty="0">
                 <a:solidFill>
                   <a:schemeClr val="bg1"/>
                 </a:solidFill>
-                <a:latin typeface="Cambria" pitchFamily="34" charset="0"/>
-                <a:ea typeface="Cambria" pitchFamily="34" charset="-122"/>
-                <a:cs typeface="Cambria" pitchFamily="34" charset="-120"/>
+                <a:latin typeface="Crimson Pro" pitchFamily="34" charset="0"/>
+                <a:ea typeface="Crimson Pro" pitchFamily="34" charset="-122"/>
+                <a:cs typeface="Crimson Pro" pitchFamily="34" charset="-120"/>
               </a:rPr>
               <a:t>Clear,</a:t>
             </a:r>
-            <a:endParaRPr lang="en-US" sz="8800" dirty="0"/>
+            <a:endParaRPr lang="en-US" sz="10000" dirty="0"/>
           </a:p>
           <a:p>
             <a:pPr algn="ctr" indent="0" marL="0">
               <a:lnSpc>
-                <a:spcPct val="105000"/>
+                <a:spcPct val="100000"/>
               </a:lnSpc>
               <a:buNone/>
             </a:pPr>
             <a:r>
-              <a:rPr lang="en-US" sz="8800" b="1" dirty="0">
+              <a:rPr lang="en-US" sz="10000" b="1" i="1" dirty="0">
                 <a:solidFill>
                   <a:schemeClr val="accent1"/>
                 </a:solidFill>
-                <a:latin typeface="Cambria" pitchFamily="34" charset="0"/>
-                <a:ea typeface="Cambria" pitchFamily="34" charset="-122"/>
-                <a:cs typeface="Cambria" pitchFamily="34" charset="-120"/>
+                <a:latin typeface="Crimson Pro" pitchFamily="34" charset="0"/>
+                <a:ea typeface="Crimson Pro" pitchFamily="34" charset="-122"/>
+                <a:cs typeface="Crimson Pro" pitchFamily="34" charset="-120"/>
               </a:rPr>
               <a:t>not native.</a:t>
             </a:r>
-            <a:endParaRPr lang="en-US" sz="8800" dirty="0"/>
+            <a:endParaRPr lang="en-US" sz="10000" dirty="0"/>
           </a:p>
         </p:txBody>
       </p:sp>
@@ -3934,14 +4087,14 @@
               <a:buNone/>
             </a:pPr>
             <a:r>
-              <a:rPr lang="en-US" sz="1600" b="1" spc="300" kern="0" dirty="0">
-                <a:solidFill>
-                  <a:schemeClr val="accent1"/>
+              <a:rPr lang="en-US" sz="1500" b="1" spc="300" kern="0" dirty="0">
+                <a:solidFill>
+                  <a:schemeClr val="accent2"/>
                 </a:solidFill>
               </a:rPr>
               <a:t>5 · LA DIFERENCIA</a:t>
             </a:r>
-            <a:endParaRPr lang="en-US" sz="1600" dirty="0"/>
+            <a:endParaRPr lang="en-US" sz="1500" dirty="0"/>
           </a:p>
         </p:txBody>
       </p:sp>
@@ -3968,56 +4121,56 @@
           <a:p>
             <a:pPr indent="0" marL="0">
               <a:lnSpc>
-                <a:spcPct val="105000"/>
+                <a:spcPct val="100000"/>
               </a:lnSpc>
               <a:buNone/>
             </a:pPr>
             <a:r>
-              <a:rPr lang="en-US" sz="5000" b="1" dirty="0">
-                <a:solidFill>
-                  <a:schemeClr val="bg1"/>
-                </a:solidFill>
-                <a:latin typeface="Cambria" pitchFamily="34" charset="0"/>
-                <a:ea typeface="Cambria" pitchFamily="34" charset="-122"/>
-                <a:cs typeface="Cambria" pitchFamily="34" charset="-120"/>
+              <a:rPr lang="en-US" sz="5800" b="1" dirty="0">
+                <a:solidFill>
+                  <a:schemeClr val="tx1"/>
+                </a:solidFill>
+                <a:latin typeface="Crimson Pro" pitchFamily="34" charset="0"/>
+                <a:ea typeface="Crimson Pro" pitchFamily="34" charset="-122"/>
+                <a:cs typeface="Crimson Pro" pitchFamily="34" charset="-120"/>
               </a:rPr>
               <a:t>Saber inglés y </a:t>
             </a:r>
             <a:pPr indent="0" marL="0">
               <a:lnSpc>
-                <a:spcPct val="105000"/>
+                <a:spcPct val="100000"/>
               </a:lnSpc>
               <a:buNone/>
             </a:pPr>
             <a:r>
-              <a:rPr lang="en-US" sz="5000" b="1" dirty="0">
-                <a:solidFill>
-                  <a:schemeClr val="accent1"/>
-                </a:solidFill>
-                <a:latin typeface="Cambria" pitchFamily="34" charset="0"/>
-                <a:ea typeface="Cambria" pitchFamily="34" charset="-122"/>
-                <a:cs typeface="Cambria" pitchFamily="34" charset="-120"/>
+              <a:rPr lang="en-US" sz="5800" b="1" i="1" dirty="0">
+                <a:solidFill>
+                  <a:schemeClr val="tx2"/>
+                </a:solidFill>
+                <a:latin typeface="Crimson Pro" pitchFamily="34" charset="0"/>
+                <a:ea typeface="Crimson Pro" pitchFamily="34" charset="-122"/>
+                <a:cs typeface="Crimson Pro" pitchFamily="34" charset="-120"/>
               </a:rPr>
               <a:t>tenerlo disponible</a:t>
             </a:r>
             <a:pPr indent="0" marL="0">
               <a:lnSpc>
-                <a:spcPct val="105000"/>
+                <a:spcPct val="100000"/>
               </a:lnSpc>
               <a:buNone/>
             </a:pPr>
             <a:r>
-              <a:rPr lang="en-US" sz="5000" b="1" dirty="0">
-                <a:solidFill>
-                  <a:schemeClr val="bg1"/>
-                </a:solidFill>
-                <a:latin typeface="Cambria" pitchFamily="34" charset="0"/>
-                <a:ea typeface="Cambria" pitchFamily="34" charset="-122"/>
-                <a:cs typeface="Cambria" pitchFamily="34" charset="-120"/>
+              <a:rPr lang="en-US" sz="5800" b="1" dirty="0">
+                <a:solidFill>
+                  <a:schemeClr val="tx1"/>
+                </a:solidFill>
+                <a:latin typeface="Crimson Pro" pitchFamily="34" charset="0"/>
+                <a:ea typeface="Crimson Pro" pitchFamily="34" charset="-122"/>
+                <a:cs typeface="Crimson Pro" pitchFamily="34" charset="-120"/>
               </a:rPr>
               <a:t> no son lo mismo</a:t>
             </a:r>
-            <a:endParaRPr lang="en-US" sz="5000" dirty="0"/>
+            <a:endParaRPr lang="en-US" sz="5800" dirty="0"/>
           </a:p>
         </p:txBody>
       </p:sp>
@@ -4051,7 +4204,7 @@
             <a:lvl1pPr>
               <a:defRPr sz="1100">
                 <a:solidFill>
-                  <a:schemeClr val="bg2"/>
+                  <a:schemeClr val="accent5"/>
                 </a:solidFill>
               </a:defRPr>
             </a:lvl1pPr>
@@ -4118,20 +4271,47 @@
               <a:buNone/>
             </a:pPr>
             <a:r>
-              <a:rPr lang="en-US" sz="1600" b="1" spc="300" kern="0" dirty="0">
-                <a:solidFill>
-                  <a:schemeClr val="accent1"/>
+              <a:rPr lang="en-US" sz="1500" b="1" spc="300" kern="0" dirty="0">
+                <a:solidFill>
+                  <a:schemeClr val="accent2"/>
                 </a:solidFill>
               </a:rPr>
               <a:t>5 · DISPONIBLE CUANDO LO NECESITÁS</a:t>
             </a:r>
-            <a:endParaRPr lang="en-US" sz="1600" dirty="0"/>
-          </a:p>
-        </p:txBody>
+            <a:endParaRPr lang="en-US" sz="1500" dirty="0"/>
+          </a:p>
+        </p:txBody>
+      </p:sp>
+      <p:sp>
+        <p:nvSpPr>
+          <p:cNvPr id="3" name="marco"/>
+          <p:cNvSpPr/>
+          <p:nvPr/>
+        </p:nvSpPr>
+        <p:spPr>
+          <a:xfrm>
+            <a:off x="5440680" y="2372319"/>
+            <a:ext cx="6181344" cy="3302081"/>
+          </a:xfrm>
+          <a:prstGeom prst="roundRect">
+            <a:avLst>
+              <a:gd name="adj" fmla="val 5538"/>
+            </a:avLst>
+          </a:prstGeom>
+          <a:solidFill>
+            <a:schemeClr val="bg2"/>
+          </a:solidFill>
+          <a:ln w="12700">
+            <a:solidFill>
+              <a:schemeClr val="accent2"/>
+            </a:solidFill>
+            <a:prstDash val="solid"/>
+          </a:ln>
+        </p:spPr>
       </p:sp>
       <p:pic>
         <p:nvPicPr>
-          <p:cNvPr id="3" name="captura" descr="Captura del mensaje de Un evento en inglés en la comunidad">    </p:cNvPr>
+          <p:cNvPr id="4" name="captura" descr="Captura del mensaje de Un evento en inglés en la comunidad">    </p:cNvPr>
           <p:cNvPicPr>
             <a:picLocks noChangeAspect="1"/>
           </p:cNvPicPr>
@@ -4145,53 +4325,14 @@
         </p:blipFill>
         <p:spPr>
           <a:xfrm>
-            <a:off x="5788152" y="2583363"/>
-            <a:ext cx="5669280" cy="2879994"/>
+            <a:off x="5605272" y="2536911"/>
+            <a:ext cx="5852160" cy="2972897"/>
           </a:xfrm>
           <a:prstGeom prst="rect">
             <a:avLst/>
           </a:prstGeom>
         </p:spPr>
       </p:pic>
-      <p:sp>
-        <p:nvSpPr>
-          <p:cNvPr id="4" name="Text 1"/>
-          <p:cNvSpPr txBox="1"/>
-          <p:nvPr/>
-        </p:nvSpPr>
-        <p:spPr>
-          <a:xfrm>
-            <a:off x="731520" y="2194560"/>
-            <a:ext cx="4507992" cy="914400"/>
-          </a:xfrm>
-          <a:prstGeom prst="rect">
-            <a:avLst/>
-          </a:prstGeom>
-          <a:noFill/>
-          <a:ln/>
-        </p:spPr>
-        <p:txBody>
-          <a:bodyPr wrap="square" lIns="0" tIns="0" rIns="0" bIns="0" rtlCol="0" anchor="t"/>
-          <a:lstStyle/>
-          <a:p>
-            <a:pPr indent="0" marL="0">
-              <a:buNone/>
-            </a:pPr>
-            <a:r>
-              <a:rPr lang="en-US" sz="4000" b="1" dirty="0">
-                <a:solidFill>
-                  <a:schemeClr val="bg1"/>
-                </a:solidFill>
-                <a:latin typeface="Cambria" pitchFamily="34" charset="0"/>
-                <a:ea typeface="Cambria" pitchFamily="34" charset="-122"/>
-                <a:cs typeface="Cambria" pitchFamily="34" charset="-120"/>
-              </a:rPr>
-              <a:t>Un evento en inglés</a:t>
-            </a:r>
-            <a:endParaRPr lang="en-US" sz="4000" dirty="0"/>
-          </a:p>
-        </p:txBody>
-      </p:sp>
       <p:sp>
         <p:nvSpPr>
           <p:cNvPr id="5" name="Text 2"/>
@@ -4200,8 +4341,8 @@
         </p:nvSpPr>
         <p:spPr>
           <a:xfrm>
-            <a:off x="731520" y="3200400"/>
-            <a:ext cx="4507992" cy="2011680"/>
+            <a:off x="731520" y="2103120"/>
+            <a:ext cx="4233672" cy="1463040"/>
           </a:xfrm>
           <a:prstGeom prst="rect">
             <a:avLst/>
@@ -4217,9 +4358,48 @@
               <a:buNone/>
             </a:pPr>
             <a:r>
+              <a:rPr lang="en-US" sz="4800" b="1" dirty="0">
+                <a:solidFill>
+                  <a:schemeClr val="tx2"/>
+                </a:solidFill>
+                <a:latin typeface="Crimson Pro" pitchFamily="34" charset="0"/>
+                <a:ea typeface="Crimson Pro" pitchFamily="34" charset="-122"/>
+                <a:cs typeface="Crimson Pro" pitchFamily="34" charset="-120"/>
+              </a:rPr>
+              <a:t>Un evento en inglés</a:t>
+            </a:r>
+            <a:endParaRPr lang="en-US" sz="4800" dirty="0"/>
+          </a:p>
+        </p:txBody>
+      </p:sp>
+      <p:sp>
+        <p:nvSpPr>
+          <p:cNvPr id="6" name="Text 3"/>
+          <p:cNvSpPr txBox="1"/>
+          <p:nvPr/>
+        </p:nvSpPr>
+        <p:spPr>
+          <a:xfrm>
+            <a:off x="731520" y="3657600"/>
+            <a:ext cx="4233672" cy="2194560"/>
+          </a:xfrm>
+          <a:prstGeom prst="rect">
+            <a:avLst/>
+          </a:prstGeom>
+          <a:noFill/>
+          <a:ln/>
+        </p:spPr>
+        <p:txBody>
+          <a:bodyPr wrap="square" lIns="0" tIns="0" rIns="0" bIns="0" rtlCol="0" anchor="t"/>
+          <a:lstStyle/>
+          <a:p>
+            <a:pPr indent="0" marL="0">
+              <a:buNone/>
+            </a:pPr>
+            <a:r>
               <a:rPr lang="en-US" sz="2000" dirty="0">
                 <a:solidFill>
-                  <a:schemeClr val="bg2"/>
+                  <a:schemeClr val="tx1"/>
                 </a:solidFill>
               </a:rPr>
               <a:t>No lo esperaba, entendió todo… y se animó a hacer una pregunta.</a:t>
@@ -4258,7 +4438,7 @@
             <a:lvl1pPr>
               <a:defRPr sz="1100">
                 <a:solidFill>
-                  <a:schemeClr val="bg2"/>
+                  <a:schemeClr val="accent5"/>
                 </a:solidFill>
               </a:defRPr>
             </a:lvl1pPr>
@@ -4325,14 +4505,14 @@
               <a:buNone/>
             </a:pPr>
             <a:r>
-              <a:rPr lang="en-US" sz="1600" b="1" spc="300" kern="0" dirty="0">
+              <a:rPr lang="en-US" sz="1500" b="1" spc="300" kern="0" dirty="0">
                 <a:solidFill>
                   <a:schemeClr val="accent1"/>
                 </a:solidFill>
               </a:rPr>
               <a:t>6 · A MÍ TAMBIÉN ME PASÓ</a:t>
             </a:r>
-            <a:endParaRPr lang="en-US" sz="1600" dirty="0"/>
+            <a:endParaRPr lang="en-US" sz="1500" dirty="0"/>
           </a:p>
         </p:txBody>
       </p:sp>
@@ -4359,42 +4539,42 @@
           <a:p>
             <a:pPr indent="0" marL="0">
               <a:lnSpc>
-                <a:spcPct val="105000"/>
+                <a:spcPct val="100000"/>
               </a:lnSpc>
               <a:buNone/>
             </a:pPr>
             <a:r>
-              <a:rPr lang="en-US" sz="5000" b="1" dirty="0">
+              <a:rPr lang="en-US" sz="5800" b="1" dirty="0">
                 <a:solidFill>
                   <a:schemeClr val="bg1"/>
                 </a:solidFill>
-                <a:latin typeface="Cambria" pitchFamily="34" charset="0"/>
-                <a:ea typeface="Cambria" pitchFamily="34" charset="-122"/>
-                <a:cs typeface="Cambria" pitchFamily="34" charset="-120"/>
+                <a:latin typeface="Crimson Pro" pitchFamily="34" charset="0"/>
+                <a:ea typeface="Crimson Pro" pitchFamily="34" charset="-122"/>
+                <a:cs typeface="Crimson Pro" pitchFamily="34" charset="-120"/>
               </a:rPr>
               <a:t>No era solo el inglés.</a:t>
             </a:r>
-            <a:endParaRPr lang="en-US" sz="5000" dirty="0"/>
+            <a:endParaRPr lang="en-US" sz="5800" dirty="0"/>
           </a:p>
           <a:p>
             <a:pPr indent="0" marL="0">
               <a:lnSpc>
-                <a:spcPct val="105000"/>
+                <a:spcPct val="100000"/>
               </a:lnSpc>
               <a:buNone/>
             </a:pPr>
             <a:r>
-              <a:rPr lang="en-US" sz="5000" b="1" dirty="0">
+              <a:rPr lang="en-US" sz="5800" b="1" i="1" dirty="0">
                 <a:solidFill>
                   <a:schemeClr val="accent1"/>
                 </a:solidFill>
-                <a:latin typeface="Cambria" pitchFamily="34" charset="0"/>
-                <a:ea typeface="Cambria" pitchFamily="34" charset="-122"/>
-                <a:cs typeface="Cambria" pitchFamily="34" charset="-120"/>
+                <a:latin typeface="Crimson Pro" pitchFamily="34" charset="0"/>
+                <a:ea typeface="Crimson Pro" pitchFamily="34" charset="-122"/>
+                <a:cs typeface="Crimson Pro" pitchFamily="34" charset="-120"/>
               </a:rPr>
               <a:t>Era la relación con el inglés.</a:t>
             </a:r>
-            <a:endParaRPr lang="en-US" sz="5000" dirty="0"/>
+            <a:endParaRPr lang="en-US" sz="5800" dirty="0"/>
           </a:p>
         </p:txBody>
       </p:sp>
@@ -4495,20 +4675,20 @@
               <a:buNone/>
             </a:pPr>
             <a:r>
-              <a:rPr lang="en-US" sz="1600" b="1" spc="300" kern="0" dirty="0">
-                <a:solidFill>
-                  <a:schemeClr val="accent1"/>
+              <a:rPr lang="en-US" sz="1500" b="1" spc="300" kern="0" dirty="0">
+                <a:solidFill>
+                  <a:schemeClr val="accent2"/>
                 </a:solidFill>
               </a:rPr>
               <a:t>7 · QUÉ EMPEZAMOS A CAMBIAR</a:t>
             </a:r>
-            <a:endParaRPr lang="en-US" sz="1600" dirty="0"/>
-          </a:p>
-        </p:txBody>
-      </p:sp>
-      <p:sp>
-        <p:nvSpPr>
-          <p:cNvPr id="3" name="card1"/>
+            <a:endParaRPr lang="en-US" sz="1500" dirty="0"/>
+          </a:p>
+        </p:txBody>
+      </p:sp>
+      <p:sp>
+        <p:nvSpPr>
+          <p:cNvPr id="3" name="tarjeta1"/>
           <p:cNvSpPr/>
           <p:nvPr/>
         </p:nvSpPr>
@@ -4519,15 +4699,15 @@
           </a:xfrm>
           <a:prstGeom prst="roundRect">
             <a:avLst>
-              <a:gd name="adj" fmla="val 5000"/>
+              <a:gd name="adj" fmla="val 5556"/>
             </a:avLst>
           </a:prstGeom>
           <a:solidFill>
-            <a:schemeClr val="tx2"/>
+            <a:schemeClr val="bg2"/>
           </a:solidFill>
           <a:ln w="12700">
             <a:solidFill>
-              <a:schemeClr val="accent3"/>
+              <a:schemeClr val="accent2"/>
             </a:solidFill>
             <a:prstDash val="solid"/>
           </a:ln>
@@ -4560,7 +4740,7 @@
             <a:r>
               <a:rPr lang="en-US" sz="1400" b="1" dirty="0">
                 <a:solidFill>
-                  <a:schemeClr val="bg2"/>
+                  <a:schemeClr val="accent2"/>
                 </a:solidFill>
               </a:rPr>
               <a:t>01</a:t>
@@ -4594,17 +4774,17 @@
               <a:buNone/>
             </a:pPr>
             <a:r>
-              <a:rPr lang="en-US" sz="2800" b="1" dirty="0">
-                <a:solidFill>
-                  <a:schemeClr val="accent1"/>
-                </a:solidFill>
-                <a:latin typeface="Cambria" pitchFamily="34" charset="0"/>
-                <a:ea typeface="Cambria" pitchFamily="34" charset="-122"/>
-                <a:cs typeface="Cambria" pitchFamily="34" charset="-120"/>
+              <a:rPr lang="en-US" sz="3200" b="1" dirty="0">
+                <a:solidFill>
+                  <a:schemeClr val="tx2"/>
+                </a:solidFill>
+                <a:latin typeface="Crimson Pro" pitchFamily="34" charset="0"/>
+                <a:ea typeface="Crimson Pro" pitchFamily="34" charset="-122"/>
+                <a:cs typeface="Crimson Pro" pitchFamily="34" charset="-120"/>
               </a:rPr>
               <a:t>Entrenar con tu realidad</a:t>
             </a:r>
-            <a:endParaRPr lang="en-US" sz="2800" dirty="0"/>
+            <a:endParaRPr lang="en-US" sz="3200" dirty="0"/>
           </a:p>
         </p:txBody>
       </p:sp>
@@ -4633,20 +4813,20 @@
               <a:buNone/>
             </a:pPr>
             <a:r>
-              <a:rPr lang="en-US" sz="1700" dirty="0">
-                <a:solidFill>
-                  <a:schemeClr val="bg1"/>
+              <a:rPr lang="en-US" sz="1600" dirty="0">
+                <a:solidFill>
+                  <a:schemeClr val="tx1"/>
                 </a:solidFill>
               </a:rPr>
               <a:t>Tu presentación, tu reunión, tu entrevista.</a:t>
             </a:r>
-            <a:endParaRPr lang="en-US" sz="1700" dirty="0"/>
-          </a:p>
-        </p:txBody>
-      </p:sp>
-      <p:sp>
-        <p:nvSpPr>
-          <p:cNvPr id="7" name="card2"/>
+            <a:endParaRPr lang="en-US" sz="1600" dirty="0"/>
+          </a:p>
+        </p:txBody>
+      </p:sp>
+      <p:sp>
+        <p:nvSpPr>
+          <p:cNvPr id="7" name="tarjeta2"/>
           <p:cNvSpPr/>
           <p:nvPr/>
         </p:nvSpPr>
@@ -4657,15 +4837,15 @@
           </a:xfrm>
           <a:prstGeom prst="roundRect">
             <a:avLst>
-              <a:gd name="adj" fmla="val 5000"/>
+              <a:gd name="adj" fmla="val 5556"/>
             </a:avLst>
           </a:prstGeom>
           <a:solidFill>
-            <a:schemeClr val="tx2"/>
+            <a:schemeClr val="bg2"/>
           </a:solidFill>
           <a:ln w="12700">
             <a:solidFill>
-              <a:schemeClr val="accent3"/>
+              <a:schemeClr val="accent2"/>
             </a:solidFill>
             <a:prstDash val="solid"/>
           </a:ln>
@@ -4698,7 +4878,7 @@
             <a:r>
               <a:rPr lang="en-US" sz="1400" b="1" dirty="0">
                 <a:solidFill>
-                  <a:schemeClr val="bg2"/>
+                  <a:schemeClr val="accent2"/>
                 </a:solidFill>
               </a:rPr>
               <a:t>02</a:t>
@@ -4732,17 +4912,17 @@
               <a:buNone/>
             </a:pPr>
             <a:r>
-              <a:rPr lang="en-US" sz="2800" b="1" dirty="0">
-                <a:solidFill>
-                  <a:schemeClr val="accent1"/>
-                </a:solidFill>
-                <a:latin typeface="Cambria" pitchFamily="34" charset="0"/>
-                <a:ea typeface="Cambria" pitchFamily="34" charset="-122"/>
-                <a:cs typeface="Cambria" pitchFamily="34" charset="-120"/>
+              <a:rPr lang="en-US" sz="3200" b="1" dirty="0">
+                <a:solidFill>
+                  <a:schemeClr val="tx2"/>
+                </a:solidFill>
+                <a:latin typeface="Crimson Pro" pitchFamily="34" charset="0"/>
+                <a:ea typeface="Crimson Pro" pitchFamily="34" charset="-122"/>
+                <a:cs typeface="Crimson Pro" pitchFamily="34" charset="-120"/>
               </a:rPr>
               <a:t>Salir del modo examen</a:t>
             </a:r>
-            <a:endParaRPr lang="en-US" sz="2800" dirty="0"/>
+            <a:endParaRPr lang="en-US" sz="3200" dirty="0"/>
           </a:p>
         </p:txBody>
       </p:sp>
@@ -4771,20 +4951,20 @@
               <a:buNone/>
             </a:pPr>
             <a:r>
-              <a:rPr lang="en-US" sz="1700" dirty="0">
-                <a:solidFill>
-                  <a:schemeClr val="bg1"/>
+              <a:rPr lang="en-US" sz="1600" dirty="0">
+                <a:solidFill>
+                  <a:schemeClr val="tx1"/>
                 </a:solidFill>
               </a:rPr>
               <a:t>Primero el mensaje. Después refinamos el inglés.</a:t>
             </a:r>
-            <a:endParaRPr lang="en-US" sz="1700" dirty="0"/>
-          </a:p>
-        </p:txBody>
-      </p:sp>
-      <p:sp>
-        <p:nvSpPr>
-          <p:cNvPr id="11" name="card3"/>
+            <a:endParaRPr lang="en-US" sz="1600" dirty="0"/>
+          </a:p>
+        </p:txBody>
+      </p:sp>
+      <p:sp>
+        <p:nvSpPr>
+          <p:cNvPr id="11" name="tarjeta3"/>
           <p:cNvSpPr/>
           <p:nvPr/>
         </p:nvSpPr>
@@ -4795,15 +4975,15 @@
           </a:xfrm>
           <a:prstGeom prst="roundRect">
             <a:avLst>
-              <a:gd name="adj" fmla="val 5000"/>
+              <a:gd name="adj" fmla="val 5556"/>
             </a:avLst>
           </a:prstGeom>
           <a:solidFill>
-            <a:schemeClr val="tx2"/>
+            <a:schemeClr val="bg2"/>
           </a:solidFill>
           <a:ln w="12700">
             <a:solidFill>
-              <a:schemeClr val="accent3"/>
+              <a:schemeClr val="accent2"/>
             </a:solidFill>
             <a:prstDash val="solid"/>
           </a:ln>
@@ -4836,7 +5016,7 @@
             <a:r>
               <a:rPr lang="en-US" sz="1400" b="1" dirty="0">
                 <a:solidFill>
-                  <a:schemeClr val="bg2"/>
+                  <a:schemeClr val="accent2"/>
                 </a:solidFill>
               </a:rPr>
               <a:t>03</a:t>
@@ -4870,17 +5050,17 @@
               <a:buNone/>
             </a:pPr>
             <a:r>
-              <a:rPr lang="en-US" sz="2800" b="1" dirty="0">
-                <a:solidFill>
-                  <a:schemeClr val="accent1"/>
-                </a:solidFill>
-                <a:latin typeface="Cambria" pitchFamily="34" charset="0"/>
-                <a:ea typeface="Cambria" pitchFamily="34" charset="-122"/>
-                <a:cs typeface="Cambria" pitchFamily="34" charset="-120"/>
+              <a:rPr lang="en-US" sz="3200" b="1" dirty="0">
+                <a:solidFill>
+                  <a:schemeClr val="tx2"/>
+                </a:solidFill>
+                <a:latin typeface="Crimson Pro" pitchFamily="34" charset="0"/>
+                <a:ea typeface="Crimson Pro" pitchFamily="34" charset="-122"/>
+                <a:cs typeface="Crimson Pro" pitchFamily="34" charset="-120"/>
               </a:rPr>
               <a:t>El segundo intento</a:t>
             </a:r>
-            <a:endParaRPr lang="en-US" sz="2800" dirty="0"/>
+            <a:endParaRPr lang="en-US" sz="3200" dirty="0"/>
           </a:p>
         </p:txBody>
       </p:sp>
@@ -4909,14 +5089,14 @@
               <a:buNone/>
             </a:pPr>
             <a:r>
-              <a:rPr lang="en-US" sz="1700" dirty="0">
-                <a:solidFill>
-                  <a:schemeClr val="bg1"/>
+              <a:rPr lang="en-US" sz="1600" dirty="0">
+                <a:solidFill>
+                  <a:schemeClr val="tx1"/>
                 </a:solidFill>
               </a:rPr>
               <a:t>Lo decís, miramos qué pasó y lo volvés a hacer.</a:t>
             </a:r>
-            <a:endParaRPr lang="en-US" sz="1700" dirty="0"/>
+            <a:endParaRPr lang="en-US" sz="1600" dirty="0"/>
           </a:p>
         </p:txBody>
       </p:sp>
@@ -4950,7 +5130,7 @@
             <a:lvl1pPr>
               <a:defRPr sz="1100">
                 <a:solidFill>
-                  <a:schemeClr val="bg2"/>
+                  <a:schemeClr val="accent5"/>
                 </a:solidFill>
               </a:defRPr>
             </a:lvl1pPr>
@@ -5017,14 +5197,14 @@
               <a:buNone/>
             </a:pPr>
             <a:r>
-              <a:rPr lang="en-US" sz="1600" b="1" spc="300" kern="0" dirty="0">
+              <a:rPr lang="en-US" sz="1500" b="1" spc="300" kern="0" dirty="0">
                 <a:solidFill>
                   <a:schemeClr val="accent1"/>
                 </a:solidFill>
               </a:rPr>
               <a:t>8 · PRIMERO HAY QUE DETECTAR</a:t>
             </a:r>
-            <a:endParaRPr lang="en-US" sz="1600" dirty="0"/>
+            <a:endParaRPr lang="en-US" sz="1500" dirty="0"/>
           </a:p>
         </p:txBody>
       </p:sp>
@@ -5051,42 +5231,42 @@
           <a:p>
             <a:pPr indent="0" marL="0">
               <a:lnSpc>
-                <a:spcPct val="105000"/>
+                <a:spcPct val="100000"/>
               </a:lnSpc>
               <a:buNone/>
             </a:pPr>
             <a:r>
-              <a:rPr lang="en-US" sz="5000" b="1" dirty="0">
+              <a:rPr lang="en-US" sz="5800" b="1" dirty="0">
                 <a:solidFill>
                   <a:schemeClr val="bg1"/>
                 </a:solidFill>
-                <a:latin typeface="Cambria" pitchFamily="34" charset="0"/>
-                <a:ea typeface="Cambria" pitchFamily="34" charset="-122"/>
-                <a:cs typeface="Cambria" pitchFamily="34" charset="-120"/>
+                <a:latin typeface="Crimson Pro" pitchFamily="34" charset="0"/>
+                <a:ea typeface="Crimson Pro" pitchFamily="34" charset="-122"/>
+                <a:cs typeface="Crimson Pro" pitchFamily="34" charset="-120"/>
               </a:rPr>
               <a:t>No alcanza con practicar más.</a:t>
             </a:r>
-            <a:endParaRPr lang="en-US" sz="5000" dirty="0"/>
+            <a:endParaRPr lang="en-US" sz="5800" dirty="0"/>
           </a:p>
           <a:p>
             <a:pPr indent="0" marL="0">
               <a:lnSpc>
-                <a:spcPct val="105000"/>
+                <a:spcPct val="100000"/>
               </a:lnSpc>
               <a:buNone/>
             </a:pPr>
             <a:r>
-              <a:rPr lang="en-US" sz="5000" b="1" dirty="0">
+              <a:rPr lang="en-US" sz="5800" b="1" i="1" dirty="0">
                 <a:solidFill>
                   <a:schemeClr val="accent1"/>
                 </a:solidFill>
-                <a:latin typeface="Cambria" pitchFamily="34" charset="0"/>
-                <a:ea typeface="Cambria" pitchFamily="34" charset="-122"/>
-                <a:cs typeface="Cambria" pitchFamily="34" charset="-120"/>
+                <a:latin typeface="Crimson Pro" pitchFamily="34" charset="0"/>
+                <a:ea typeface="Crimson Pro" pitchFamily="34" charset="-122"/>
+                <a:cs typeface="Crimson Pro" pitchFamily="34" charset="-120"/>
               </a:rPr>
               <a:t>Hay que saber qué practicar.</a:t>
             </a:r>
-            <a:endParaRPr lang="en-US" sz="5000" dirty="0"/>
+            <a:endParaRPr lang="en-US" sz="5800" dirty="0"/>
           </a:p>
         </p:txBody>
       </p:sp>
@@ -5187,14 +5367,14 @@
               <a:buNone/>
             </a:pPr>
             <a:r>
-              <a:rPr lang="en-US" sz="1600" b="1" spc="300" kern="0" dirty="0">
+              <a:rPr lang="en-US" sz="1500" b="1" spc="300" kern="0" dirty="0">
                 <a:solidFill>
                   <a:schemeClr val="accent1"/>
                 </a:solidFill>
               </a:rPr>
               <a:t>9 · EL DELIVERY METHOD™</a:t>
             </a:r>
-            <a:endParaRPr lang="en-US" sz="1600" dirty="0"/>
+            <a:endParaRPr lang="en-US" sz="1500" dirty="0"/>
           </a:p>
         </p:txBody>
       </p:sp>
@@ -5206,7 +5386,7 @@
         </p:nvSpPr>
         <p:spPr>
           <a:xfrm>
-            <a:off x="731520" y="2103120"/>
+            <a:off x="731520" y="2011680"/>
             <a:ext cx="10698480" cy="2743200"/>
           </a:xfrm>
           <a:prstGeom prst="rect">
@@ -5221,42 +5401,42 @@
           <a:p>
             <a:pPr algn="ctr" indent="0" marL="0">
               <a:lnSpc>
-                <a:spcPct val="105000"/>
+                <a:spcPct val="100000"/>
               </a:lnSpc>
               <a:buNone/>
             </a:pPr>
             <a:r>
-              <a:rPr lang="en-US" sz="6600" b="1" dirty="0">
+              <a:rPr lang="en-US" sz="7600" b="1" dirty="0">
                 <a:solidFill>
                   <a:schemeClr val="bg1"/>
                 </a:solidFill>
-                <a:latin typeface="Cambria" pitchFamily="34" charset="0"/>
-                <a:ea typeface="Cambria" pitchFamily="34" charset="-122"/>
-                <a:cs typeface="Cambria" pitchFamily="34" charset="-120"/>
+                <a:latin typeface="Crimson Pro" pitchFamily="34" charset="0"/>
+                <a:ea typeface="Crimson Pro" pitchFamily="34" charset="-122"/>
+                <a:cs typeface="Crimson Pro" pitchFamily="34" charset="-120"/>
               </a:rPr>
               <a:t>Usar primero,</a:t>
             </a:r>
-            <a:endParaRPr lang="en-US" sz="6600" dirty="0"/>
+            <a:endParaRPr lang="en-US" sz="7600" dirty="0"/>
           </a:p>
           <a:p>
             <a:pPr algn="ctr" indent="0" marL="0">
               <a:lnSpc>
-                <a:spcPct val="105000"/>
+                <a:spcPct val="100000"/>
               </a:lnSpc>
               <a:buNone/>
             </a:pPr>
             <a:r>
-              <a:rPr lang="en-US" sz="6600" b="1" dirty="0">
+              <a:rPr lang="en-US" sz="7600" b="1" i="1" dirty="0">
                 <a:solidFill>
                   <a:schemeClr val="accent1"/>
                 </a:solidFill>
-                <a:latin typeface="Cambria" pitchFamily="34" charset="0"/>
-                <a:ea typeface="Cambria" pitchFamily="34" charset="-122"/>
-                <a:cs typeface="Cambria" pitchFamily="34" charset="-120"/>
+                <a:latin typeface="Crimson Pro" pitchFamily="34" charset="0"/>
+                <a:ea typeface="Crimson Pro" pitchFamily="34" charset="-122"/>
+                <a:cs typeface="Crimson Pro" pitchFamily="34" charset="-120"/>
               </a:rPr>
               <a:t>aprender después.</a:t>
             </a:r>
-            <a:endParaRPr lang="en-US" sz="6600" dirty="0"/>
+            <a:endParaRPr lang="en-US" sz="7600" dirty="0"/>
           </a:p>
         </p:txBody>
       </p:sp>
@@ -5357,14 +5537,14 @@
               <a:buNone/>
             </a:pPr>
             <a:r>
-              <a:rPr lang="en-US" sz="1600" b="1" spc="300" kern="0" dirty="0">
-                <a:solidFill>
-                  <a:schemeClr val="accent1"/>
+              <a:rPr lang="en-US" sz="1500" b="1" spc="300" kern="0" dirty="0">
+                <a:solidFill>
+                  <a:schemeClr val="accent2"/>
                 </a:solidFill>
               </a:rPr>
               <a:t>9 · EL DELIVERY METHOD™</a:t>
             </a:r>
-            <a:endParaRPr lang="en-US" sz="1600" dirty="0"/>
+            <a:endParaRPr lang="en-US" sz="1500" dirty="0"/>
           </a:p>
         </p:txBody>
       </p:sp>
@@ -5381,7 +5561,313 @@
           </a:xfrm>
           <a:prstGeom prst="roundRect">
             <a:avLst>
-              <a:gd name="adj" fmla="val 10000"/>
+              <a:gd name="adj" fmla="val 11111"/>
+            </a:avLst>
+          </a:prstGeom>
+          <a:solidFill>
+            <a:schemeClr val="bg2"/>
+          </a:solidFill>
+          <a:ln w="12700">
+            <a:solidFill>
+              <a:schemeClr val="accent2"/>
+            </a:solidFill>
+            <a:prstDash val="solid"/>
+          </a:ln>
+        </p:spPr>
+      </p:sp>
+      <p:sp>
+        <p:nvSpPr>
+          <p:cNvPr id="4" name="Text 2"/>
+          <p:cNvSpPr txBox="1"/>
+          <p:nvPr/>
+        </p:nvSpPr>
+        <p:spPr>
+          <a:xfrm>
+            <a:off x="731520" y="2377440"/>
+            <a:ext cx="2286000" cy="1645920"/>
+          </a:xfrm>
+          <a:prstGeom prst="rect">
+            <a:avLst/>
+          </a:prstGeom>
+          <a:noFill/>
+          <a:ln/>
+        </p:spPr>
+        <p:txBody>
+          <a:bodyPr wrap="square" lIns="1270" tIns="1270" rIns="1270" bIns="1270" rtlCol="0" anchor="ctr"/>
+          <a:lstStyle/>
+          <a:p>
+            <a:pPr algn="ctr" indent="0" marL="0">
+              <a:buNone/>
+            </a:pPr>
+            <a:r>
+              <a:rPr lang="en-US" sz="3000" b="1" dirty="0">
+                <a:solidFill>
+                  <a:schemeClr val="tx2"/>
+                </a:solidFill>
+                <a:latin typeface="Crimson Pro" pitchFamily="34" charset="0"/>
+                <a:ea typeface="Crimson Pro" pitchFamily="34" charset="-122"/>
+                <a:cs typeface="Crimson Pro" pitchFamily="34" charset="-120"/>
+              </a:rPr>
+              <a:t>Producir</a:t>
+            </a:r>
+            <a:endParaRPr lang="en-US" sz="3000" dirty="0"/>
+          </a:p>
+        </p:txBody>
+      </p:sp>
+      <p:sp>
+        <p:nvSpPr>
+          <p:cNvPr id="5" name="Text 3"/>
+          <p:cNvSpPr txBox="1"/>
+          <p:nvPr/>
+        </p:nvSpPr>
+        <p:spPr>
+          <a:xfrm>
+            <a:off x="3017520" y="2377440"/>
+            <a:ext cx="521208" cy="1645920"/>
+          </a:xfrm>
+          <a:prstGeom prst="rect">
+            <a:avLst/>
+          </a:prstGeom>
+          <a:noFill/>
+          <a:ln/>
+        </p:spPr>
+        <p:txBody>
+          <a:bodyPr wrap="square" lIns="0" tIns="0" rIns="0" bIns="0" rtlCol="0" anchor="ctr"/>
+          <a:lstStyle/>
+          <a:p>
+            <a:pPr algn="ctr" indent="0" marL="0">
+              <a:buNone/>
+            </a:pPr>
+            <a:r>
+              <a:rPr lang="en-US" sz="3000" dirty="0">
+                <a:solidFill>
+                  <a:schemeClr val="accent2"/>
+                </a:solidFill>
+              </a:rPr>
+              <a:t>→</a:t>
+            </a:r>
+            <a:endParaRPr lang="en-US" sz="3000" dirty="0"/>
+          </a:p>
+        </p:txBody>
+      </p:sp>
+      <p:sp>
+        <p:nvSpPr>
+          <p:cNvPr id="6" name="paso2"/>
+          <p:cNvSpPr/>
+          <p:nvPr/>
+        </p:nvSpPr>
+        <p:spPr>
+          <a:xfrm>
+            <a:off x="3538728" y="2377440"/>
+            <a:ext cx="2286000" cy="1645920"/>
+          </a:xfrm>
+          <a:prstGeom prst="roundRect">
+            <a:avLst>
+              <a:gd name="adj" fmla="val 11111"/>
+            </a:avLst>
+          </a:prstGeom>
+          <a:solidFill>
+            <a:schemeClr val="bg2"/>
+          </a:solidFill>
+          <a:ln w="12700">
+            <a:solidFill>
+              <a:schemeClr val="accent2"/>
+            </a:solidFill>
+            <a:prstDash val="solid"/>
+          </a:ln>
+        </p:spPr>
+      </p:sp>
+      <p:sp>
+        <p:nvSpPr>
+          <p:cNvPr id="7" name="Text 5"/>
+          <p:cNvSpPr txBox="1"/>
+          <p:nvPr/>
+        </p:nvSpPr>
+        <p:spPr>
+          <a:xfrm>
+            <a:off x="3538728" y="2377440"/>
+            <a:ext cx="2286000" cy="1645920"/>
+          </a:xfrm>
+          <a:prstGeom prst="rect">
+            <a:avLst/>
+          </a:prstGeom>
+          <a:noFill/>
+          <a:ln/>
+        </p:spPr>
+        <p:txBody>
+          <a:bodyPr wrap="square" lIns="1270" tIns="1270" rIns="1270" bIns="1270" rtlCol="0" anchor="ctr"/>
+          <a:lstStyle/>
+          <a:p>
+            <a:pPr algn="ctr" indent="0" marL="0">
+              <a:buNone/>
+            </a:pPr>
+            <a:r>
+              <a:rPr lang="en-US" sz="3000" b="1" dirty="0">
+                <a:solidFill>
+                  <a:schemeClr val="tx2"/>
+                </a:solidFill>
+                <a:latin typeface="Crimson Pro" pitchFamily="34" charset="0"/>
+                <a:ea typeface="Crimson Pro" pitchFamily="34" charset="-122"/>
+                <a:cs typeface="Crimson Pro" pitchFamily="34" charset="-120"/>
+              </a:rPr>
+              <a:t>Detectar</a:t>
+            </a:r>
+            <a:endParaRPr lang="en-US" sz="3000" dirty="0"/>
+          </a:p>
+        </p:txBody>
+      </p:sp>
+      <p:sp>
+        <p:nvSpPr>
+          <p:cNvPr id="8" name="Text 6"/>
+          <p:cNvSpPr txBox="1"/>
+          <p:nvPr/>
+        </p:nvSpPr>
+        <p:spPr>
+          <a:xfrm>
+            <a:off x="5824728" y="2377440"/>
+            <a:ext cx="521208" cy="1645920"/>
+          </a:xfrm>
+          <a:prstGeom prst="rect">
+            <a:avLst/>
+          </a:prstGeom>
+          <a:noFill/>
+          <a:ln/>
+        </p:spPr>
+        <p:txBody>
+          <a:bodyPr wrap="square" lIns="0" tIns="0" rIns="0" bIns="0" rtlCol="0" anchor="ctr"/>
+          <a:lstStyle/>
+          <a:p>
+            <a:pPr algn="ctr" indent="0" marL="0">
+              <a:buNone/>
+            </a:pPr>
+            <a:r>
+              <a:rPr lang="en-US" sz="3000" dirty="0">
+                <a:solidFill>
+                  <a:schemeClr val="accent2"/>
+                </a:solidFill>
+              </a:rPr>
+              <a:t>→</a:t>
+            </a:r>
+            <a:endParaRPr lang="en-US" sz="3000" dirty="0"/>
+          </a:p>
+        </p:txBody>
+      </p:sp>
+      <p:sp>
+        <p:nvSpPr>
+          <p:cNvPr id="9" name="paso3"/>
+          <p:cNvSpPr/>
+          <p:nvPr/>
+        </p:nvSpPr>
+        <p:spPr>
+          <a:xfrm>
+            <a:off x="6345936" y="2377440"/>
+            <a:ext cx="2286000" cy="1645920"/>
+          </a:xfrm>
+          <a:prstGeom prst="roundRect">
+            <a:avLst>
+              <a:gd name="adj" fmla="val 11111"/>
+            </a:avLst>
+          </a:prstGeom>
+          <a:solidFill>
+            <a:schemeClr val="bg2"/>
+          </a:solidFill>
+          <a:ln w="12700">
+            <a:solidFill>
+              <a:schemeClr val="accent2"/>
+            </a:solidFill>
+            <a:prstDash val="solid"/>
+          </a:ln>
+        </p:spPr>
+      </p:sp>
+      <p:sp>
+        <p:nvSpPr>
+          <p:cNvPr id="10" name="Text 8"/>
+          <p:cNvSpPr txBox="1"/>
+          <p:nvPr/>
+        </p:nvSpPr>
+        <p:spPr>
+          <a:xfrm>
+            <a:off x="6345936" y="2377440"/>
+            <a:ext cx="2286000" cy="1645920"/>
+          </a:xfrm>
+          <a:prstGeom prst="rect">
+            <a:avLst/>
+          </a:prstGeom>
+          <a:noFill/>
+          <a:ln/>
+        </p:spPr>
+        <p:txBody>
+          <a:bodyPr wrap="square" lIns="1270" tIns="1270" rIns="1270" bIns="1270" rtlCol="0" anchor="ctr"/>
+          <a:lstStyle/>
+          <a:p>
+            <a:pPr algn="ctr" indent="0" marL="0">
+              <a:buNone/>
+            </a:pPr>
+            <a:r>
+              <a:rPr lang="en-US" sz="3000" b="1" dirty="0">
+                <a:solidFill>
+                  <a:schemeClr val="tx2"/>
+                </a:solidFill>
+                <a:latin typeface="Crimson Pro" pitchFamily="34" charset="0"/>
+                <a:ea typeface="Crimson Pro" pitchFamily="34" charset="-122"/>
+                <a:cs typeface="Crimson Pro" pitchFamily="34" charset="-120"/>
+              </a:rPr>
+              <a:t>Corregir y refinar</a:t>
+            </a:r>
+            <a:endParaRPr lang="en-US" sz="3000" dirty="0"/>
+          </a:p>
+        </p:txBody>
+      </p:sp>
+      <p:sp>
+        <p:nvSpPr>
+          <p:cNvPr id="11" name="Text 9"/>
+          <p:cNvSpPr txBox="1"/>
+          <p:nvPr/>
+        </p:nvSpPr>
+        <p:spPr>
+          <a:xfrm>
+            <a:off x="8631936" y="2377440"/>
+            <a:ext cx="521208" cy="1645920"/>
+          </a:xfrm>
+          <a:prstGeom prst="rect">
+            <a:avLst/>
+          </a:prstGeom>
+          <a:noFill/>
+          <a:ln/>
+        </p:spPr>
+        <p:txBody>
+          <a:bodyPr wrap="square" lIns="0" tIns="0" rIns="0" bIns="0" rtlCol="0" anchor="ctr"/>
+          <a:lstStyle/>
+          <a:p>
+            <a:pPr algn="ctr" indent="0" marL="0">
+              <a:buNone/>
+            </a:pPr>
+            <a:r>
+              <a:rPr lang="en-US" sz="3000" dirty="0">
+                <a:solidFill>
+                  <a:schemeClr val="accent2"/>
+                </a:solidFill>
+              </a:rPr>
+              <a:t>→</a:t>
+            </a:r>
+            <a:endParaRPr lang="en-US" sz="3000" dirty="0"/>
+          </a:p>
+        </p:txBody>
+      </p:sp>
+      <p:sp>
+        <p:nvSpPr>
+          <p:cNvPr id="12" name="paso4"/>
+          <p:cNvSpPr/>
+          <p:nvPr/>
+        </p:nvSpPr>
+        <p:spPr>
+          <a:xfrm>
+            <a:off x="9153144" y="2377440"/>
+            <a:ext cx="2286000" cy="1645920"/>
+          </a:xfrm>
+          <a:prstGeom prst="roundRect">
+            <a:avLst>
+              <a:gd name="adj" fmla="val 11111"/>
             </a:avLst>
           </a:prstGeom>
           <a:solidFill>
@@ -5389,7 +5875,7 @@
           </a:solidFill>
           <a:ln w="12700">
             <a:solidFill>
-              <a:schemeClr val="accent3"/>
+              <a:schemeClr val="accent2"/>
             </a:solidFill>
             <a:prstDash val="solid"/>
           </a:ln>
@@ -5397,312 +5883,6 @@
       </p:sp>
       <p:sp>
         <p:nvSpPr>
-          <p:cNvPr id="4" name="Text 2"/>
-          <p:cNvSpPr txBox="1"/>
-          <p:nvPr/>
-        </p:nvSpPr>
-        <p:spPr>
-          <a:xfrm>
-            <a:off x="731520" y="2377440"/>
-            <a:ext cx="2286000" cy="1645920"/>
-          </a:xfrm>
-          <a:prstGeom prst="rect">
-            <a:avLst/>
-          </a:prstGeom>
-          <a:noFill/>
-          <a:ln/>
-        </p:spPr>
-        <p:txBody>
-          <a:bodyPr wrap="square" lIns="1270" tIns="1270" rIns="1270" bIns="1270" rtlCol="0" anchor="ctr"/>
-          <a:lstStyle/>
-          <a:p>
-            <a:pPr algn="ctr" indent="0" marL="0">
-              <a:buNone/>
-            </a:pPr>
-            <a:r>
-              <a:rPr lang="en-US" sz="2600" b="1" dirty="0">
-                <a:solidFill>
-                  <a:schemeClr val="bg1"/>
-                </a:solidFill>
-                <a:latin typeface="Cambria" pitchFamily="34" charset="0"/>
-                <a:ea typeface="Cambria" pitchFamily="34" charset="-122"/>
-                <a:cs typeface="Cambria" pitchFamily="34" charset="-120"/>
-              </a:rPr>
-              <a:t>Producir</a:t>
-            </a:r>
-            <a:endParaRPr lang="en-US" sz="2600" dirty="0"/>
-          </a:p>
-        </p:txBody>
-      </p:sp>
-      <p:sp>
-        <p:nvSpPr>
-          <p:cNvPr id="5" name="Text 3"/>
-          <p:cNvSpPr txBox="1"/>
-          <p:nvPr/>
-        </p:nvSpPr>
-        <p:spPr>
-          <a:xfrm>
-            <a:off x="3017520" y="2377440"/>
-            <a:ext cx="521208" cy="1645920"/>
-          </a:xfrm>
-          <a:prstGeom prst="rect">
-            <a:avLst/>
-          </a:prstGeom>
-          <a:noFill/>
-          <a:ln/>
-        </p:spPr>
-        <p:txBody>
-          <a:bodyPr wrap="square" lIns="0" tIns="0" rIns="0" bIns="0" rtlCol="0" anchor="ctr"/>
-          <a:lstStyle/>
-          <a:p>
-            <a:pPr algn="ctr" indent="0" marL="0">
-              <a:buNone/>
-            </a:pPr>
-            <a:r>
-              <a:rPr lang="en-US" sz="3000" dirty="0">
-                <a:solidFill>
-                  <a:schemeClr val="accent1"/>
-                </a:solidFill>
-              </a:rPr>
-              <a:t>→</a:t>
-            </a:r>
-            <a:endParaRPr lang="en-US" sz="3000" dirty="0"/>
-          </a:p>
-        </p:txBody>
-      </p:sp>
-      <p:sp>
-        <p:nvSpPr>
-          <p:cNvPr id="6" name="paso2"/>
-          <p:cNvSpPr/>
-          <p:nvPr/>
-        </p:nvSpPr>
-        <p:spPr>
-          <a:xfrm>
-            <a:off x="3538728" y="2377440"/>
-            <a:ext cx="2286000" cy="1645920"/>
-          </a:xfrm>
-          <a:prstGeom prst="roundRect">
-            <a:avLst>
-              <a:gd name="adj" fmla="val 10000"/>
-            </a:avLst>
-          </a:prstGeom>
-          <a:solidFill>
-            <a:schemeClr val="tx2"/>
-          </a:solidFill>
-          <a:ln w="12700">
-            <a:solidFill>
-              <a:schemeClr val="accent3"/>
-            </a:solidFill>
-            <a:prstDash val="solid"/>
-          </a:ln>
-        </p:spPr>
-      </p:sp>
-      <p:sp>
-        <p:nvSpPr>
-          <p:cNvPr id="7" name="Text 5"/>
-          <p:cNvSpPr txBox="1"/>
-          <p:nvPr/>
-        </p:nvSpPr>
-        <p:spPr>
-          <a:xfrm>
-            <a:off x="3538728" y="2377440"/>
-            <a:ext cx="2286000" cy="1645920"/>
-          </a:xfrm>
-          <a:prstGeom prst="rect">
-            <a:avLst/>
-          </a:prstGeom>
-          <a:noFill/>
-          <a:ln/>
-        </p:spPr>
-        <p:txBody>
-          <a:bodyPr wrap="square" lIns="1270" tIns="1270" rIns="1270" bIns="1270" rtlCol="0" anchor="ctr"/>
-          <a:lstStyle/>
-          <a:p>
-            <a:pPr algn="ctr" indent="0" marL="0">
-              <a:buNone/>
-            </a:pPr>
-            <a:r>
-              <a:rPr lang="en-US" sz="2600" b="1" dirty="0">
-                <a:solidFill>
-                  <a:schemeClr val="bg1"/>
-                </a:solidFill>
-                <a:latin typeface="Cambria" pitchFamily="34" charset="0"/>
-                <a:ea typeface="Cambria" pitchFamily="34" charset="-122"/>
-                <a:cs typeface="Cambria" pitchFamily="34" charset="-120"/>
-              </a:rPr>
-              <a:t>Detectar</a:t>
-            </a:r>
-            <a:endParaRPr lang="en-US" sz="2600" dirty="0"/>
-          </a:p>
-        </p:txBody>
-      </p:sp>
-      <p:sp>
-        <p:nvSpPr>
-          <p:cNvPr id="8" name="Text 6"/>
-          <p:cNvSpPr txBox="1"/>
-          <p:nvPr/>
-        </p:nvSpPr>
-        <p:spPr>
-          <a:xfrm>
-            <a:off x="5824728" y="2377440"/>
-            <a:ext cx="521208" cy="1645920"/>
-          </a:xfrm>
-          <a:prstGeom prst="rect">
-            <a:avLst/>
-          </a:prstGeom>
-          <a:noFill/>
-          <a:ln/>
-        </p:spPr>
-        <p:txBody>
-          <a:bodyPr wrap="square" lIns="0" tIns="0" rIns="0" bIns="0" rtlCol="0" anchor="ctr"/>
-          <a:lstStyle/>
-          <a:p>
-            <a:pPr algn="ctr" indent="0" marL="0">
-              <a:buNone/>
-            </a:pPr>
-            <a:r>
-              <a:rPr lang="en-US" sz="3000" dirty="0">
-                <a:solidFill>
-                  <a:schemeClr val="accent1"/>
-                </a:solidFill>
-              </a:rPr>
-              <a:t>→</a:t>
-            </a:r>
-            <a:endParaRPr lang="en-US" sz="3000" dirty="0"/>
-          </a:p>
-        </p:txBody>
-      </p:sp>
-      <p:sp>
-        <p:nvSpPr>
-          <p:cNvPr id="9" name="paso3"/>
-          <p:cNvSpPr/>
-          <p:nvPr/>
-        </p:nvSpPr>
-        <p:spPr>
-          <a:xfrm>
-            <a:off x="6345936" y="2377440"/>
-            <a:ext cx="2286000" cy="1645920"/>
-          </a:xfrm>
-          <a:prstGeom prst="roundRect">
-            <a:avLst>
-              <a:gd name="adj" fmla="val 10000"/>
-            </a:avLst>
-          </a:prstGeom>
-          <a:solidFill>
-            <a:schemeClr val="tx2"/>
-          </a:solidFill>
-          <a:ln w="12700">
-            <a:solidFill>
-              <a:schemeClr val="accent3"/>
-            </a:solidFill>
-            <a:prstDash val="solid"/>
-          </a:ln>
-        </p:spPr>
-      </p:sp>
-      <p:sp>
-        <p:nvSpPr>
-          <p:cNvPr id="10" name="Text 8"/>
-          <p:cNvSpPr txBox="1"/>
-          <p:nvPr/>
-        </p:nvSpPr>
-        <p:spPr>
-          <a:xfrm>
-            <a:off x="6345936" y="2377440"/>
-            <a:ext cx="2286000" cy="1645920"/>
-          </a:xfrm>
-          <a:prstGeom prst="rect">
-            <a:avLst/>
-          </a:prstGeom>
-          <a:noFill/>
-          <a:ln/>
-        </p:spPr>
-        <p:txBody>
-          <a:bodyPr wrap="square" lIns="1270" tIns="1270" rIns="1270" bIns="1270" rtlCol="0" anchor="ctr"/>
-          <a:lstStyle/>
-          <a:p>
-            <a:pPr algn="ctr" indent="0" marL="0">
-              <a:buNone/>
-            </a:pPr>
-            <a:r>
-              <a:rPr lang="en-US" sz="2600" b="1" dirty="0">
-                <a:solidFill>
-                  <a:schemeClr val="bg1"/>
-                </a:solidFill>
-                <a:latin typeface="Cambria" pitchFamily="34" charset="0"/>
-                <a:ea typeface="Cambria" pitchFamily="34" charset="-122"/>
-                <a:cs typeface="Cambria" pitchFamily="34" charset="-120"/>
-              </a:rPr>
-              <a:t>Corregir y refinar</a:t>
-            </a:r>
-            <a:endParaRPr lang="en-US" sz="2600" dirty="0"/>
-          </a:p>
-        </p:txBody>
-      </p:sp>
-      <p:sp>
-        <p:nvSpPr>
-          <p:cNvPr id="11" name="Text 9"/>
-          <p:cNvSpPr txBox="1"/>
-          <p:nvPr/>
-        </p:nvSpPr>
-        <p:spPr>
-          <a:xfrm>
-            <a:off x="8631936" y="2377440"/>
-            <a:ext cx="521208" cy="1645920"/>
-          </a:xfrm>
-          <a:prstGeom prst="rect">
-            <a:avLst/>
-          </a:prstGeom>
-          <a:noFill/>
-          <a:ln/>
-        </p:spPr>
-        <p:txBody>
-          <a:bodyPr wrap="square" lIns="0" tIns="0" rIns="0" bIns="0" rtlCol="0" anchor="ctr"/>
-          <a:lstStyle/>
-          <a:p>
-            <a:pPr algn="ctr" indent="0" marL="0">
-              <a:buNone/>
-            </a:pPr>
-            <a:r>
-              <a:rPr lang="en-US" sz="3000" dirty="0">
-                <a:solidFill>
-                  <a:schemeClr val="accent1"/>
-                </a:solidFill>
-              </a:rPr>
-              <a:t>→</a:t>
-            </a:r>
-            <a:endParaRPr lang="en-US" sz="3000" dirty="0"/>
-          </a:p>
-        </p:txBody>
-      </p:sp>
-      <p:sp>
-        <p:nvSpPr>
-          <p:cNvPr id="12" name="paso4"/>
-          <p:cNvSpPr/>
-          <p:nvPr/>
-        </p:nvSpPr>
-        <p:spPr>
-          <a:xfrm>
-            <a:off x="9153144" y="2377440"/>
-            <a:ext cx="2286000" cy="1645920"/>
-          </a:xfrm>
-          <a:prstGeom prst="roundRect">
-            <a:avLst>
-              <a:gd name="adj" fmla="val 10000"/>
-            </a:avLst>
-          </a:prstGeom>
-          <a:solidFill>
-            <a:schemeClr val="accent1"/>
-          </a:solidFill>
-          <a:ln w="12700">
-            <a:solidFill>
-              <a:schemeClr val="accent3"/>
-            </a:solidFill>
-            <a:prstDash val="solid"/>
-          </a:ln>
-        </p:spPr>
-      </p:sp>
-      <p:sp>
-        <p:nvSpPr>
           <p:cNvPr id="13" name="Text 11"/>
           <p:cNvSpPr txBox="1"/>
           <p:nvPr/>
@@ -5726,17 +5906,17 @@
               <a:buNone/>
             </a:pPr>
             <a:r>
-              <a:rPr lang="en-US" sz="2600" b="1" dirty="0">
-                <a:solidFill>
-                  <a:schemeClr val="tx1"/>
-                </a:solidFill>
-                <a:latin typeface="Cambria" pitchFamily="34" charset="0"/>
-                <a:ea typeface="Cambria" pitchFamily="34" charset="-122"/>
-                <a:cs typeface="Cambria" pitchFamily="34" charset="-120"/>
+              <a:rPr lang="en-US" sz="3000" b="1" dirty="0">
+                <a:solidFill>
+                  <a:schemeClr val="bg1"/>
+                </a:solidFill>
+                <a:latin typeface="Crimson Pro" pitchFamily="34" charset="0"/>
+                <a:ea typeface="Crimson Pro" pitchFamily="34" charset="-122"/>
+                <a:cs typeface="Crimson Pro" pitchFamily="34" charset="-120"/>
               </a:rPr>
               <a:t>Aplicar</a:t>
             </a:r>
-            <a:endParaRPr lang="en-US" sz="2600" dirty="0"/>
+            <a:endParaRPr lang="en-US" sz="3000" dirty="0"/>
           </a:p>
         </p:txBody>
       </p:sp>
@@ -5770,7 +5950,7 @@
             <a:lvl1pPr>
               <a:defRPr sz="1100">
                 <a:solidFill>
-                  <a:schemeClr val="bg2"/>
+                  <a:schemeClr val="accent5"/>
                 </a:solidFill>
               </a:defRPr>
             </a:lvl1pPr>
@@ -5837,20 +6017,20 @@
               <a:buNone/>
             </a:pPr>
             <a:r>
-              <a:rPr lang="en-US" sz="1600" b="1" spc="300" kern="0" dirty="0">
-                <a:solidFill>
-                  <a:schemeClr val="accent1"/>
+              <a:rPr lang="en-US" sz="1500" b="1" spc="300" kern="0" dirty="0">
+                <a:solidFill>
+                  <a:schemeClr val="accent2"/>
                 </a:solidFill>
               </a:rPr>
               <a:t>9 · ¿QUÉ SE ROMPIÓ?</a:t>
             </a:r>
-            <a:endParaRPr lang="en-US" sz="1600" dirty="0"/>
-          </a:p>
-        </p:txBody>
-      </p:sp>
-      <p:sp>
-        <p:nvSpPr>
-          <p:cNvPr id="3" name="card1"/>
+            <a:endParaRPr lang="en-US" sz="1500" dirty="0"/>
+          </a:p>
+        </p:txBody>
+      </p:sp>
+      <p:sp>
+        <p:nvSpPr>
+          <p:cNvPr id="3" name="tarjeta1"/>
           <p:cNvSpPr/>
           <p:nvPr/>
         </p:nvSpPr>
@@ -5861,15 +6041,15 @@
           </a:xfrm>
           <a:prstGeom prst="roundRect">
             <a:avLst>
-              <a:gd name="adj" fmla="val 5000"/>
+              <a:gd name="adj" fmla="val 5556"/>
             </a:avLst>
           </a:prstGeom>
           <a:solidFill>
-            <a:schemeClr val="tx2"/>
+            <a:schemeClr val="bg2"/>
           </a:solidFill>
           <a:ln w="12700">
             <a:solidFill>
-              <a:schemeClr val="accent3"/>
+              <a:schemeClr val="accent2"/>
             </a:solidFill>
             <a:prstDash val="solid"/>
           </a:ln>
@@ -5900,17 +6080,17 @@
               <a:buNone/>
             </a:pPr>
             <a:r>
-              <a:rPr lang="en-US" sz="3600" b="1" dirty="0">
-                <a:solidFill>
-                  <a:schemeClr val="accent1"/>
-                </a:solidFill>
-                <a:latin typeface="Cambria" pitchFamily="34" charset="0"/>
-                <a:ea typeface="Cambria" pitchFamily="34" charset="-122"/>
-                <a:cs typeface="Cambria" pitchFamily="34" charset="-120"/>
+              <a:rPr lang="en-US" sz="4200" b="1" dirty="0">
+                <a:solidFill>
+                  <a:schemeClr val="tx2"/>
+                </a:solidFill>
+                <a:latin typeface="Crimson Pro" pitchFamily="34" charset="0"/>
+                <a:ea typeface="Crimson Pro" pitchFamily="34" charset="-122"/>
+                <a:cs typeface="Crimson Pro" pitchFamily="34" charset="-120"/>
               </a:rPr>
               <a:t>QUÉ</a:t>
             </a:r>
-            <a:endParaRPr lang="en-US" sz="3600" dirty="0"/>
+            <a:endParaRPr lang="en-US" sz="4200" dirty="0"/>
           </a:p>
         </p:txBody>
       </p:sp>
@@ -5939,20 +6119,20 @@
               <a:buNone/>
             </a:pPr>
             <a:r>
-              <a:rPr lang="en-US" sz="1700" dirty="0">
-                <a:solidFill>
-                  <a:schemeClr val="bg1"/>
+              <a:rPr lang="en-US" sz="1600" dirty="0">
+                <a:solidFill>
+                  <a:schemeClr val="tx1"/>
                 </a:solidFill>
               </a:rPr>
               <a:t>El mensaje. No sabés cuál es la idea principal o cómo ordenarla.</a:t>
             </a:r>
-            <a:endParaRPr lang="en-US" sz="1700" dirty="0"/>
-          </a:p>
-        </p:txBody>
-      </p:sp>
-      <p:sp>
-        <p:nvSpPr>
-          <p:cNvPr id="6" name="card2"/>
+            <a:endParaRPr lang="en-US" sz="1600" dirty="0"/>
+          </a:p>
+        </p:txBody>
+      </p:sp>
+      <p:sp>
+        <p:nvSpPr>
+          <p:cNvPr id="6" name="tarjeta2"/>
           <p:cNvSpPr/>
           <p:nvPr/>
         </p:nvSpPr>
@@ -5963,15 +6143,15 @@
           </a:xfrm>
           <a:prstGeom prst="roundRect">
             <a:avLst>
-              <a:gd name="adj" fmla="val 5000"/>
+              <a:gd name="adj" fmla="val 5556"/>
             </a:avLst>
           </a:prstGeom>
           <a:solidFill>
-            <a:schemeClr val="tx2"/>
+            <a:schemeClr val="bg2"/>
           </a:solidFill>
           <a:ln w="12700">
             <a:solidFill>
-              <a:schemeClr val="accent3"/>
+              <a:schemeClr val="accent2"/>
             </a:solidFill>
             <a:prstDash val="solid"/>
           </a:ln>
@@ -6002,17 +6182,17 @@
               <a:buNone/>
             </a:pPr>
             <a:r>
-              <a:rPr lang="en-US" sz="3600" b="1" dirty="0">
-                <a:solidFill>
-                  <a:schemeClr val="accent1"/>
-                </a:solidFill>
-                <a:latin typeface="Cambria" pitchFamily="34" charset="0"/>
-                <a:ea typeface="Cambria" pitchFamily="34" charset="-122"/>
-                <a:cs typeface="Cambria" pitchFamily="34" charset="-120"/>
+              <a:rPr lang="en-US" sz="4200" b="1" dirty="0">
+                <a:solidFill>
+                  <a:schemeClr val="tx2"/>
+                </a:solidFill>
+                <a:latin typeface="Crimson Pro" pitchFamily="34" charset="0"/>
+                <a:ea typeface="Crimson Pro" pitchFamily="34" charset="-122"/>
+                <a:cs typeface="Crimson Pro" pitchFamily="34" charset="-120"/>
               </a:rPr>
               <a:t>CÓMO</a:t>
             </a:r>
-            <a:endParaRPr lang="en-US" sz="3600" dirty="0"/>
+            <a:endParaRPr lang="en-US" sz="4200" dirty="0"/>
           </a:p>
         </p:txBody>
       </p:sp>
@@ -6041,20 +6221,20 @@
               <a:buNone/>
             </a:pPr>
             <a:r>
-              <a:rPr lang="en-US" sz="1700" dirty="0">
-                <a:solidFill>
-                  <a:schemeClr val="bg1"/>
+              <a:rPr lang="en-US" sz="1600" dirty="0">
+                <a:solidFill>
+                  <a:schemeClr val="tx1"/>
                 </a:solidFill>
               </a:rPr>
               <a:t>El idioma. Estructura, vocabulario, pronunciación o listening.</a:t>
             </a:r>
-            <a:endParaRPr lang="en-US" sz="1700" dirty="0"/>
-          </a:p>
-        </p:txBody>
-      </p:sp>
-      <p:sp>
-        <p:nvSpPr>
-          <p:cNvPr id="9" name="card3"/>
+            <a:endParaRPr lang="en-US" sz="1600" dirty="0"/>
+          </a:p>
+        </p:txBody>
+      </p:sp>
+      <p:sp>
+        <p:nvSpPr>
+          <p:cNvPr id="9" name="tarjeta3"/>
           <p:cNvSpPr/>
           <p:nvPr/>
         </p:nvSpPr>
@@ -6065,15 +6245,15 @@
           </a:xfrm>
           <a:prstGeom prst="roundRect">
             <a:avLst>
-              <a:gd name="adj" fmla="val 5000"/>
+              <a:gd name="adj" fmla="val 5556"/>
             </a:avLst>
           </a:prstGeom>
           <a:solidFill>
-            <a:schemeClr val="tx2"/>
+            <a:schemeClr val="bg2"/>
           </a:solidFill>
           <a:ln w="12700">
             <a:solidFill>
-              <a:schemeClr val="accent3"/>
+              <a:schemeClr val="accent2"/>
             </a:solidFill>
             <a:prstDash val="solid"/>
           </a:ln>
@@ -6104,17 +6284,17 @@
               <a:buNone/>
             </a:pPr>
             <a:r>
-              <a:rPr lang="en-US" sz="3600" b="1" dirty="0">
-                <a:solidFill>
-                  <a:schemeClr val="accent1"/>
-                </a:solidFill>
-                <a:latin typeface="Cambria" pitchFamily="34" charset="0"/>
-                <a:ea typeface="Cambria" pitchFamily="34" charset="-122"/>
-                <a:cs typeface="Cambria" pitchFamily="34" charset="-120"/>
+              <a:rPr lang="en-US" sz="4200" b="1" dirty="0">
+                <a:solidFill>
+                  <a:schemeClr val="tx2"/>
+                </a:solidFill>
+                <a:latin typeface="Crimson Pro" pitchFamily="34" charset="0"/>
+                <a:ea typeface="Crimson Pro" pitchFamily="34" charset="-122"/>
+                <a:cs typeface="Crimson Pro" pitchFamily="34" charset="-120"/>
               </a:rPr>
               <a:t>QUIÉN</a:t>
             </a:r>
-            <a:endParaRPr lang="en-US" sz="3600" dirty="0"/>
+            <a:endParaRPr lang="en-US" sz="4200" dirty="0"/>
           </a:p>
         </p:txBody>
       </p:sp>
@@ -6143,14 +6323,14 @@
               <a:buNone/>
             </a:pPr>
             <a:r>
-              <a:rPr lang="en-US" sz="1700" dirty="0">
-                <a:solidFill>
-                  <a:schemeClr val="bg1"/>
+              <a:rPr lang="en-US" sz="1600" dirty="0">
+                <a:solidFill>
+                  <a:schemeClr val="tx1"/>
                 </a:solidFill>
               </a:rPr>
               <a:t>Desde dónde hablás. Sabés qué decir, tenés el inglés… y no hablás.</a:t>
             </a:r>
-            <a:endParaRPr lang="en-US" sz="1700" dirty="0"/>
+            <a:endParaRPr lang="en-US" sz="1600" dirty="0"/>
           </a:p>
         </p:txBody>
       </p:sp>
@@ -6184,7 +6364,7 @@
             <a:lvl1pPr>
               <a:defRPr sz="1100">
                 <a:solidFill>
-                  <a:schemeClr val="bg2"/>
+                  <a:schemeClr val="accent5"/>
                 </a:solidFill>
               </a:defRPr>
             </a:lvl1pPr>
@@ -6251,20 +6431,47 @@
               <a:buNone/>
             </a:pPr>
             <a:r>
-              <a:rPr lang="en-US" sz="1600" b="1" spc="300" kern="0" dirty="0">
-                <a:solidFill>
-                  <a:schemeClr val="accent1"/>
+              <a:rPr lang="en-US" sz="1500" b="1" spc="300" kern="0" dirty="0">
+                <a:solidFill>
+                  <a:schemeClr val="accent2"/>
                 </a:solidFill>
               </a:rPr>
               <a:t>9 · DETECTAR</a:t>
             </a:r>
-            <a:endParaRPr lang="en-US" sz="1600" dirty="0"/>
-          </a:p>
-        </p:txBody>
+            <a:endParaRPr lang="en-US" sz="1500" dirty="0"/>
+          </a:p>
+        </p:txBody>
+      </p:sp>
+      <p:sp>
+        <p:nvSpPr>
+          <p:cNvPr id="3" name="marco"/>
+          <p:cNvSpPr/>
+          <p:nvPr/>
+        </p:nvSpPr>
+        <p:spPr>
+          <a:xfrm>
+            <a:off x="5440680" y="2395728"/>
+            <a:ext cx="6181344" cy="3255264"/>
+          </a:xfrm>
+          <a:prstGeom prst="roundRect">
+            <a:avLst>
+              <a:gd name="adj" fmla="val 5618"/>
+            </a:avLst>
+          </a:prstGeom>
+          <a:solidFill>
+            <a:schemeClr val="bg2"/>
+          </a:solidFill>
+          <a:ln w="12700">
+            <a:solidFill>
+              <a:schemeClr val="accent2"/>
+            </a:solidFill>
+            <a:prstDash val="solid"/>
+          </a:ln>
+        </p:spPr>
       </p:sp>
       <p:pic>
         <p:nvPicPr>
-          <p:cNvPr id="3" name="captura" descr="Captura del mensaje de Lauri en la comunidad">    </p:cNvPr>
+          <p:cNvPr id="4" name="captura" descr="Captura del mensaje de Lauri en la comunidad">    </p:cNvPr>
           <p:cNvPicPr>
             <a:picLocks noChangeAspect="1"/>
           </p:cNvPicPr>
@@ -6278,53 +6485,14 @@
         </p:blipFill>
         <p:spPr>
           <a:xfrm>
-            <a:off x="5788152" y="2606040"/>
-            <a:ext cx="5669280" cy="2834640"/>
+            <a:off x="5605272" y="2560320"/>
+            <a:ext cx="5852160" cy="2926080"/>
           </a:xfrm>
           <a:prstGeom prst="rect">
             <a:avLst/>
           </a:prstGeom>
         </p:spPr>
       </p:pic>
-      <p:sp>
-        <p:nvSpPr>
-          <p:cNvPr id="4" name="Text 1"/>
-          <p:cNvSpPr txBox="1"/>
-          <p:nvPr/>
-        </p:nvSpPr>
-        <p:spPr>
-          <a:xfrm>
-            <a:off x="731520" y="2194560"/>
-            <a:ext cx="4507992" cy="914400"/>
-          </a:xfrm>
-          <a:prstGeom prst="rect">
-            <a:avLst/>
-          </a:prstGeom>
-          <a:noFill/>
-          <a:ln/>
-        </p:spPr>
-        <p:txBody>
-          <a:bodyPr wrap="square" lIns="0" tIns="0" rIns="0" bIns="0" rtlCol="0" anchor="t"/>
-          <a:lstStyle/>
-          <a:p>
-            <a:pPr indent="0" marL="0">
-              <a:buNone/>
-            </a:pPr>
-            <a:r>
-              <a:rPr lang="en-US" sz="4000" b="1" dirty="0">
-                <a:solidFill>
-                  <a:schemeClr val="bg1"/>
-                </a:solidFill>
-                <a:latin typeface="Cambria" pitchFamily="34" charset="0"/>
-                <a:ea typeface="Cambria" pitchFamily="34" charset="-122"/>
-                <a:cs typeface="Cambria" pitchFamily="34" charset="-120"/>
-              </a:rPr>
-              <a:t>Lauri</a:t>
-            </a:r>
-            <a:endParaRPr lang="en-US" sz="4000" dirty="0"/>
-          </a:p>
-        </p:txBody>
-      </p:sp>
       <p:sp>
         <p:nvSpPr>
           <p:cNvPr id="5" name="Text 2"/>
@@ -6333,8 +6501,8 @@
         </p:nvSpPr>
         <p:spPr>
           <a:xfrm>
-            <a:off x="731520" y="3200400"/>
-            <a:ext cx="4507992" cy="2011680"/>
+            <a:off x="731520" y="2103120"/>
+            <a:ext cx="4233672" cy="1463040"/>
           </a:xfrm>
           <a:prstGeom prst="rect">
             <a:avLst/>
@@ -6350,9 +6518,48 @@
               <a:buNone/>
             </a:pPr>
             <a:r>
+              <a:rPr lang="en-US" sz="4800" b="1" dirty="0">
+                <a:solidFill>
+                  <a:schemeClr val="tx2"/>
+                </a:solidFill>
+                <a:latin typeface="Crimson Pro" pitchFamily="34" charset="0"/>
+                <a:ea typeface="Crimson Pro" pitchFamily="34" charset="-122"/>
+                <a:cs typeface="Crimson Pro" pitchFamily="34" charset="-120"/>
+              </a:rPr>
+              <a:t>Lauri</a:t>
+            </a:r>
+            <a:endParaRPr lang="en-US" sz="4800" dirty="0"/>
+          </a:p>
+        </p:txBody>
+      </p:sp>
+      <p:sp>
+        <p:nvSpPr>
+          <p:cNvPr id="6" name="Text 3"/>
+          <p:cNvSpPr txBox="1"/>
+          <p:nvPr/>
+        </p:nvSpPr>
+        <p:spPr>
+          <a:xfrm>
+            <a:off x="731520" y="3657600"/>
+            <a:ext cx="4233672" cy="2194560"/>
+          </a:xfrm>
+          <a:prstGeom prst="rect">
+            <a:avLst/>
+          </a:prstGeom>
+          <a:noFill/>
+          <a:ln/>
+        </p:spPr>
+        <p:txBody>
+          <a:bodyPr wrap="square" lIns="0" tIns="0" rIns="0" bIns="0" rtlCol="0" anchor="t"/>
+          <a:lstStyle/>
+          <a:p>
+            <a:pPr indent="0" marL="0">
+              <a:buNone/>
+            </a:pPr>
+            <a:r>
               <a:rPr lang="en-US" sz="2000" dirty="0">
                 <a:solidFill>
-                  <a:schemeClr val="bg2"/>
+                  <a:schemeClr val="tx1"/>
                 </a:solidFill>
               </a:rPr>
               <a:t>Detectar qué la estaba condicionando para hablar en inglés.</a:t>
@@ -6391,7 +6598,7 @@
             <a:lvl1pPr>
               <a:defRPr sz="1100">
                 <a:solidFill>
-                  <a:schemeClr val="bg2"/>
+                  <a:schemeClr val="accent5"/>
                 </a:solidFill>
               </a:defRPr>
             </a:lvl1pPr>
@@ -6458,14 +6665,14 @@
               <a:buNone/>
             </a:pPr>
             <a:r>
-              <a:rPr lang="en-US" sz="1600" b="1" spc="300" kern="0" dirty="0">
+              <a:rPr lang="en-US" sz="1500" b="1" spc="300" kern="0" dirty="0">
                 <a:solidFill>
                   <a:schemeClr val="accent1"/>
                 </a:solidFill>
               </a:rPr>
               <a:t>1 · OPENING</a:t>
             </a:r>
-            <a:endParaRPr lang="en-US" sz="1600" dirty="0"/>
+            <a:endParaRPr lang="en-US" sz="1500" dirty="0"/>
           </a:p>
         </p:txBody>
       </p:sp>
@@ -6494,17 +6701,17 @@
               <a:buNone/>
             </a:pPr>
             <a:r>
-              <a:rPr lang="en-US" sz="4600" i="1" dirty="0">
+              <a:rPr lang="en-US" sz="5200" i="1" dirty="0">
                 <a:solidFill>
                   <a:schemeClr val="bg1"/>
                 </a:solidFill>
-                <a:latin typeface="Cambria" pitchFamily="34" charset="0"/>
-                <a:ea typeface="Cambria" pitchFamily="34" charset="-122"/>
-                <a:cs typeface="Cambria" pitchFamily="34" charset="-120"/>
+                <a:latin typeface="Crimson Pro" pitchFamily="34" charset="0"/>
+                <a:ea typeface="Crimson Pro" pitchFamily="34" charset="-122"/>
+                <a:cs typeface="Crimson Pro" pitchFamily="34" charset="-120"/>
               </a:rPr>
               <a:t>“¿Cómo puede ser que ahora sí me salga, si yo sabía lo que quería decir?”</a:t>
             </a:r>
-            <a:endParaRPr lang="en-US" sz="4600" dirty="0"/>
+            <a:endParaRPr lang="en-US" sz="5200" dirty="0"/>
           </a:p>
         </p:txBody>
       </p:sp>
@@ -6605,20 +6812,47 @@
               <a:buNone/>
             </a:pPr>
             <a:r>
-              <a:rPr lang="en-US" sz="1600" b="1" spc="300" kern="0" dirty="0">
-                <a:solidFill>
-                  <a:schemeClr val="accent1"/>
+              <a:rPr lang="en-US" sz="1500" b="1" spc="300" kern="0" dirty="0">
+                <a:solidFill>
+                  <a:schemeClr val="accent2"/>
                 </a:solidFill>
               </a:rPr>
               <a:t>9 · EL CÓMO</a:t>
             </a:r>
-            <a:endParaRPr lang="en-US" sz="1600" dirty="0"/>
-          </a:p>
-        </p:txBody>
+            <a:endParaRPr lang="en-US" sz="1500" dirty="0"/>
+          </a:p>
+        </p:txBody>
+      </p:sp>
+      <p:sp>
+        <p:nvSpPr>
+          <p:cNvPr id="3" name="marco"/>
+          <p:cNvSpPr/>
+          <p:nvPr/>
+        </p:nvSpPr>
+        <p:spPr>
+          <a:xfrm>
+            <a:off x="5440680" y="2536180"/>
+            <a:ext cx="6181344" cy="2974360"/>
+          </a:xfrm>
+          <a:prstGeom prst="roundRect">
+            <a:avLst>
+              <a:gd name="adj" fmla="val 6149"/>
+            </a:avLst>
+          </a:prstGeom>
+          <a:solidFill>
+            <a:schemeClr val="bg2"/>
+          </a:solidFill>
+          <a:ln w="12700">
+            <a:solidFill>
+              <a:schemeClr val="accent2"/>
+            </a:solidFill>
+            <a:prstDash val="solid"/>
+          </a:ln>
+        </p:spPr>
       </p:sp>
       <p:pic>
         <p:nvPicPr>
-          <p:cNvPr id="3" name="captura" descr="Captura del mensaje de Virginia en la comunidad">    </p:cNvPr>
+          <p:cNvPr id="4" name="captura" descr="Captura del mensaje de Virginia en la comunidad">    </p:cNvPr>
           <p:cNvPicPr>
             <a:picLocks noChangeAspect="1"/>
           </p:cNvPicPr>
@@ -6632,53 +6866,14 @@
         </p:blipFill>
         <p:spPr>
           <a:xfrm>
-            <a:off x="5788152" y="2742103"/>
-            <a:ext cx="5669280" cy="2562515"/>
+            <a:off x="5605272" y="2700772"/>
+            <a:ext cx="5852160" cy="2645176"/>
           </a:xfrm>
           <a:prstGeom prst="rect">
             <a:avLst/>
           </a:prstGeom>
         </p:spPr>
       </p:pic>
-      <p:sp>
-        <p:nvSpPr>
-          <p:cNvPr id="4" name="Text 1"/>
-          <p:cNvSpPr txBox="1"/>
-          <p:nvPr/>
-        </p:nvSpPr>
-        <p:spPr>
-          <a:xfrm>
-            <a:off x="731520" y="2194560"/>
-            <a:ext cx="4507992" cy="914400"/>
-          </a:xfrm>
-          <a:prstGeom prst="rect">
-            <a:avLst/>
-          </a:prstGeom>
-          <a:noFill/>
-          <a:ln/>
-        </p:spPr>
-        <p:txBody>
-          <a:bodyPr wrap="square" lIns="0" tIns="0" rIns="0" bIns="0" rtlCol="0" anchor="t"/>
-          <a:lstStyle/>
-          <a:p>
-            <a:pPr indent="0" marL="0">
-              <a:buNone/>
-            </a:pPr>
-            <a:r>
-              <a:rPr lang="en-US" sz="4000" b="1" dirty="0">
-                <a:solidFill>
-                  <a:schemeClr val="bg1"/>
-                </a:solidFill>
-                <a:latin typeface="Cambria" pitchFamily="34" charset="0"/>
-                <a:ea typeface="Cambria" pitchFamily="34" charset="-122"/>
-                <a:cs typeface="Cambria" pitchFamily="34" charset="-120"/>
-              </a:rPr>
-              <a:t>Virginia</a:t>
-            </a:r>
-            <a:endParaRPr lang="en-US" sz="4000" dirty="0"/>
-          </a:p>
-        </p:txBody>
-      </p:sp>
       <p:sp>
         <p:nvSpPr>
           <p:cNvPr id="5" name="Text 2"/>
@@ -6687,8 +6882,8 @@
         </p:nvSpPr>
         <p:spPr>
           <a:xfrm>
-            <a:off x="731520" y="3200400"/>
-            <a:ext cx="4507992" cy="2011680"/>
+            <a:off x="731520" y="2103120"/>
+            <a:ext cx="4233672" cy="1463040"/>
           </a:xfrm>
           <a:prstGeom prst="rect">
             <a:avLst/>
@@ -6704,9 +6899,48 @@
               <a:buNone/>
             </a:pPr>
             <a:r>
+              <a:rPr lang="en-US" sz="4800" b="1" dirty="0">
+                <a:solidFill>
+                  <a:schemeClr val="tx2"/>
+                </a:solidFill>
+                <a:latin typeface="Crimson Pro" pitchFamily="34" charset="0"/>
+                <a:ea typeface="Crimson Pro" pitchFamily="34" charset="-122"/>
+                <a:cs typeface="Crimson Pro" pitchFamily="34" charset="-120"/>
+              </a:rPr>
+              <a:t>Virginia</a:t>
+            </a:r>
+            <a:endParaRPr lang="en-US" sz="4800" dirty="0"/>
+          </a:p>
+        </p:txBody>
+      </p:sp>
+      <p:sp>
+        <p:nvSpPr>
+          <p:cNvPr id="6" name="Text 3"/>
+          <p:cNvSpPr txBox="1"/>
+          <p:nvPr/>
+        </p:nvSpPr>
+        <p:spPr>
+          <a:xfrm>
+            <a:off x="731520" y="3657600"/>
+            <a:ext cx="4233672" cy="2194560"/>
+          </a:xfrm>
+          <a:prstGeom prst="rect">
+            <a:avLst/>
+          </a:prstGeom>
+          <a:noFill/>
+          <a:ln/>
+        </p:spPr>
+        <p:txBody>
+          <a:bodyPr wrap="square" lIns="0" tIns="0" rIns="0" bIns="0" rtlCol="0" anchor="t"/>
+          <a:lstStyle/>
+          <a:p>
+            <a:pPr indent="0" marL="0">
+              <a:buNone/>
+            </a:pPr>
+            <a:r>
               <a:rPr lang="en-US" sz="2000" dirty="0">
                 <a:solidFill>
-                  <a:schemeClr val="bg2"/>
+                  <a:schemeClr val="tx1"/>
                 </a:solidFill>
               </a:rPr>
               <a:t>Identificar sus errores fosilizados y entrenarlos.</a:t>
@@ -6745,7 +6979,7 @@
             <a:lvl1pPr>
               <a:defRPr sz="1100">
                 <a:solidFill>
-                  <a:schemeClr val="bg2"/>
+                  <a:schemeClr val="accent5"/>
                 </a:solidFill>
               </a:defRPr>
             </a:lvl1pPr>
@@ -6812,20 +7046,47 @@
               <a:buNone/>
             </a:pPr>
             <a:r>
-              <a:rPr lang="en-US" sz="1600" b="1" spc="300" kern="0" dirty="0">
-                <a:solidFill>
-                  <a:schemeClr val="accent1"/>
+              <a:rPr lang="en-US" sz="1500" b="1" spc="300" kern="0" dirty="0">
+                <a:solidFill>
+                  <a:schemeClr val="accent2"/>
                 </a:solidFill>
               </a:rPr>
               <a:t>9 · EL QUIÉN</a:t>
             </a:r>
-            <a:endParaRPr lang="en-US" sz="1600" dirty="0"/>
-          </a:p>
-        </p:txBody>
+            <a:endParaRPr lang="en-US" sz="1500" dirty="0"/>
+          </a:p>
+        </p:txBody>
+      </p:sp>
+      <p:sp>
+        <p:nvSpPr>
+          <p:cNvPr id="3" name="marco"/>
+          <p:cNvSpPr/>
+          <p:nvPr/>
+        </p:nvSpPr>
+        <p:spPr>
+          <a:xfrm>
+            <a:off x="6651216" y="1572768"/>
+            <a:ext cx="4970808" cy="4901184"/>
+          </a:xfrm>
+          <a:prstGeom prst="roundRect">
+            <a:avLst>
+              <a:gd name="adj" fmla="val 3731"/>
+            </a:avLst>
+          </a:prstGeom>
+          <a:solidFill>
+            <a:schemeClr val="bg2"/>
+          </a:solidFill>
+          <a:ln w="12700">
+            <a:solidFill>
+              <a:schemeClr val="accent2"/>
+            </a:solidFill>
+            <a:prstDash val="solid"/>
+          </a:ln>
+        </p:spPr>
       </p:sp>
       <p:pic>
         <p:nvPicPr>
-          <p:cNvPr id="3" name="captura" descr="Captura del mensaje de Sol en la comunidad">    </p:cNvPr>
+          <p:cNvPr id="4" name="captura" descr="Captura del mensaje de Sol en la comunidad">    </p:cNvPr>
           <p:cNvPicPr>
             <a:picLocks noChangeAspect="1"/>
           </p:cNvPicPr>
@@ -6849,53 +7110,14 @@
       </p:pic>
       <p:sp>
         <p:nvSpPr>
-          <p:cNvPr id="4" name="Text 1"/>
-          <p:cNvSpPr txBox="1"/>
-          <p:nvPr/>
-        </p:nvSpPr>
-        <p:spPr>
-          <a:xfrm>
-            <a:off x="731520" y="2194560"/>
-            <a:ext cx="5535648" cy="914400"/>
-          </a:xfrm>
-          <a:prstGeom prst="rect">
-            <a:avLst/>
-          </a:prstGeom>
-          <a:noFill/>
-          <a:ln/>
-        </p:spPr>
-        <p:txBody>
-          <a:bodyPr wrap="square" lIns="0" tIns="0" rIns="0" bIns="0" rtlCol="0" anchor="t"/>
-          <a:lstStyle/>
-          <a:p>
-            <a:pPr indent="0" marL="0">
-              <a:buNone/>
-            </a:pPr>
-            <a:r>
-              <a:rPr lang="en-US" sz="4000" b="1" dirty="0">
-                <a:solidFill>
-                  <a:schemeClr val="bg1"/>
-                </a:solidFill>
-                <a:latin typeface="Cambria" pitchFamily="34" charset="0"/>
-                <a:ea typeface="Cambria" pitchFamily="34" charset="-122"/>
-                <a:cs typeface="Cambria" pitchFamily="34" charset="-120"/>
-              </a:rPr>
-              <a:t>Sol</a:t>
-            </a:r>
-            <a:endParaRPr lang="en-US" sz="4000" dirty="0"/>
-          </a:p>
-        </p:txBody>
-      </p:sp>
-      <p:sp>
-        <p:nvSpPr>
           <p:cNvPr id="5" name="Text 2"/>
           <p:cNvSpPr txBox="1"/>
           <p:nvPr/>
         </p:nvSpPr>
         <p:spPr>
           <a:xfrm>
-            <a:off x="731520" y="3200400"/>
-            <a:ext cx="5535648" cy="2011680"/>
+            <a:off x="731520" y="2103120"/>
+            <a:ext cx="5444208" cy="1463040"/>
           </a:xfrm>
           <a:prstGeom prst="rect">
             <a:avLst/>
@@ -6911,9 +7133,48 @@
               <a:buNone/>
             </a:pPr>
             <a:r>
+              <a:rPr lang="en-US" sz="4800" b="1" dirty="0">
+                <a:solidFill>
+                  <a:schemeClr val="tx2"/>
+                </a:solidFill>
+                <a:latin typeface="Crimson Pro" pitchFamily="34" charset="0"/>
+                <a:ea typeface="Crimson Pro" pitchFamily="34" charset="-122"/>
+                <a:cs typeface="Crimson Pro" pitchFamily="34" charset="-120"/>
+              </a:rPr>
+              <a:t>Sol</a:t>
+            </a:r>
+            <a:endParaRPr lang="en-US" sz="4800" dirty="0"/>
+          </a:p>
+        </p:txBody>
+      </p:sp>
+      <p:sp>
+        <p:nvSpPr>
+          <p:cNvPr id="6" name="Text 3"/>
+          <p:cNvSpPr txBox="1"/>
+          <p:nvPr/>
+        </p:nvSpPr>
+        <p:spPr>
+          <a:xfrm>
+            <a:off x="731520" y="3657600"/>
+            <a:ext cx="5444208" cy="2194560"/>
+          </a:xfrm>
+          <a:prstGeom prst="rect">
+            <a:avLst/>
+          </a:prstGeom>
+          <a:noFill/>
+          <a:ln/>
+        </p:spPr>
+        <p:txBody>
+          <a:bodyPr wrap="square" lIns="0" tIns="0" rIns="0" bIns="0" rtlCol="0" anchor="t"/>
+          <a:lstStyle/>
+          <a:p>
+            <a:pPr indent="0" marL="0">
+              <a:buNone/>
+            </a:pPr>
+            <a:r>
               <a:rPr lang="en-US" sz="2000" dirty="0">
                 <a:solidFill>
-                  <a:schemeClr val="bg2"/>
+                  <a:schemeClr val="tx1"/>
                 </a:solidFill>
               </a:rPr>
               <a:t>Se vale tomarse el tiempo para hablar.</a:t>
@@ -6952,7 +7213,7 @@
             <a:lvl1pPr>
               <a:defRPr sz="1100">
                 <a:solidFill>
-                  <a:schemeClr val="bg2"/>
+                  <a:schemeClr val="accent5"/>
                 </a:solidFill>
               </a:defRPr>
             </a:lvl1pPr>
@@ -7019,14 +7280,14 @@
               <a:buNone/>
             </a:pPr>
             <a:r>
-              <a:rPr lang="en-US" sz="1600" b="1" spc="300" kern="0" dirty="0">
+              <a:rPr lang="en-US" sz="1500" b="1" spc="300" kern="0" dirty="0">
                 <a:solidFill>
                   <a:schemeClr val="accent1"/>
                 </a:solidFill>
               </a:rPr>
               <a:t>9 · LA PREGUNTA CLAVE</a:t>
             </a:r>
-            <a:endParaRPr lang="en-US" sz="1600" dirty="0"/>
+            <a:endParaRPr lang="en-US" sz="1500" dirty="0"/>
           </a:p>
         </p:txBody>
       </p:sp>
@@ -7038,7 +7299,7 @@
         </p:nvSpPr>
         <p:spPr>
           <a:xfrm>
-            <a:off x="731520" y="2286000"/>
+            <a:off x="731520" y="2194560"/>
             <a:ext cx="10698480" cy="1828800"/>
           </a:xfrm>
           <a:prstGeom prst="rect">
@@ -7055,17 +7316,17 @@
               <a:buNone/>
             </a:pPr>
             <a:r>
-              <a:rPr lang="en-US" sz="6000" i="1" dirty="0">
+              <a:rPr lang="en-US" sz="6600" i="1" dirty="0">
                 <a:solidFill>
                   <a:schemeClr val="bg1"/>
                 </a:solidFill>
-                <a:latin typeface="Cambria" pitchFamily="34" charset="0"/>
-                <a:ea typeface="Cambria" pitchFamily="34" charset="-122"/>
-                <a:cs typeface="Cambria" pitchFamily="34" charset="-120"/>
+                <a:latin typeface="Crimson Pro" pitchFamily="34" charset="0"/>
+                <a:ea typeface="Crimson Pro" pitchFamily="34" charset="-122"/>
+                <a:cs typeface="Crimson Pro" pitchFamily="34" charset="-120"/>
               </a:rPr>
               <a:t>“¿No me sale, o no me animo?”</a:t>
             </a:r>
-            <a:endParaRPr lang="en-US" sz="6000" dirty="0"/>
+            <a:endParaRPr lang="en-US" sz="6600" dirty="0"/>
           </a:p>
         </p:txBody>
       </p:sp>
@@ -7166,14 +7427,14 @@
               <a:buNone/>
             </a:pPr>
             <a:r>
-              <a:rPr lang="en-US" sz="1600" b="1" spc="300" kern="0" dirty="0">
-                <a:solidFill>
-                  <a:schemeClr val="accent1"/>
+              <a:rPr lang="en-US" sz="1500" b="1" spc="300" kern="0" dirty="0">
+                <a:solidFill>
+                  <a:schemeClr val="accent2"/>
                 </a:solidFill>
               </a:rPr>
               <a:t>10 · CÓMO TRABAJAMOS</a:t>
             </a:r>
-            <a:endParaRPr lang="en-US" sz="1600" dirty="0"/>
+            <a:endParaRPr lang="en-US" sz="1500" dirty="0"/>
           </a:p>
         </p:txBody>
       </p:sp>
@@ -7200,22 +7461,22 @@
           <a:p>
             <a:pPr indent="0" marL="0">
               <a:lnSpc>
-                <a:spcPct val="105000"/>
+                <a:spcPct val="100000"/>
               </a:lnSpc>
               <a:buNone/>
             </a:pPr>
             <a:r>
-              <a:rPr lang="en-US" sz="4400" b="1" dirty="0">
-                <a:solidFill>
-                  <a:schemeClr val="bg1"/>
-                </a:solidFill>
-                <a:latin typeface="Cambria" pitchFamily="34" charset="0"/>
-                <a:ea typeface="Cambria" pitchFamily="34" charset="-122"/>
-                <a:cs typeface="Cambria" pitchFamily="34" charset="-120"/>
+              <a:rPr lang="en-US" sz="5000" b="1" dirty="0">
+                <a:solidFill>
+                  <a:schemeClr val="tx1"/>
+                </a:solidFill>
+                <a:latin typeface="Crimson Pro" pitchFamily="34" charset="0"/>
+                <a:ea typeface="Crimson Pro" pitchFamily="34" charset="-122"/>
+                <a:cs typeface="Crimson Pro" pitchFamily="34" charset="-120"/>
               </a:rPr>
               <a:t>AT WORK no es un curso más de inglés</a:t>
             </a:r>
-            <a:endParaRPr lang="en-US" sz="4400" dirty="0"/>
+            <a:endParaRPr lang="en-US" sz="5000" dirty="0"/>
           </a:p>
         </p:txBody>
       </p:sp>
@@ -7227,7 +7488,7 @@
         </p:nvSpPr>
         <p:spPr>
           <a:xfrm>
-            <a:off x="731520" y="3474720"/>
+            <a:off x="731520" y="3383280"/>
             <a:ext cx="9601200" cy="1463040"/>
           </a:xfrm>
           <a:prstGeom prst="rect">
@@ -7244,14 +7505,14 @@
               <a:buNone/>
             </a:pPr>
             <a:r>
-              <a:rPr lang="en-US" sz="2200" dirty="0">
-                <a:solidFill>
-                  <a:schemeClr val="bg2"/>
+              <a:rPr lang="en-US" sz="2000" dirty="0">
+                <a:solidFill>
+                  <a:schemeClr val="tx1"/>
                 </a:solidFill>
               </a:rPr>
               <a:t>Una metodología propia: tu material real, un diagnóstico de qué se rompe en tu caso y acompañamiento para que al final puedas detectarlo y entrenarlo vos sola.</a:t>
             </a:r>
-            <a:endParaRPr lang="en-US" sz="2200" dirty="0"/>
+            <a:endParaRPr lang="en-US" sz="2000" dirty="0"/>
           </a:p>
         </p:txBody>
       </p:sp>
@@ -7285,7 +7546,7 @@
             <a:lvl1pPr>
               <a:defRPr sz="1100">
                 <a:solidFill>
-                  <a:schemeClr val="bg2"/>
+                  <a:schemeClr val="accent5"/>
                 </a:solidFill>
               </a:defRPr>
             </a:lvl1pPr>
@@ -7352,14 +7613,14 @@
               <a:buNone/>
             </a:pPr>
             <a:r>
-              <a:rPr lang="en-US" sz="1600" b="1" spc="300" kern="0" dirty="0">
-                <a:solidFill>
-                  <a:schemeClr val="accent1"/>
+              <a:rPr lang="en-US" sz="1500" b="1" spc="300" kern="0" dirty="0">
+                <a:solidFill>
+                  <a:schemeClr val="accent2"/>
                 </a:solidFill>
               </a:rPr>
               <a:t>10 · LA COMUNIDAD</a:t>
             </a:r>
-            <a:endParaRPr lang="en-US" sz="1600" dirty="0"/>
+            <a:endParaRPr lang="en-US" sz="1500" dirty="0"/>
           </a:p>
         </p:txBody>
       </p:sp>
@@ -7388,23 +7649,50 @@
               <a:buNone/>
             </a:pPr>
             <a:r>
-              <a:rPr lang="en-US" sz="3200" b="1" dirty="0">
-                <a:solidFill>
-                  <a:schemeClr val="bg1"/>
-                </a:solidFill>
-                <a:latin typeface="Cambria" pitchFamily="34" charset="0"/>
-                <a:ea typeface="Cambria" pitchFamily="34" charset="-122"/>
-                <a:cs typeface="Cambria" pitchFamily="34" charset="-120"/>
+              <a:rPr lang="en-US" sz="3600" b="1" dirty="0">
+                <a:solidFill>
+                  <a:schemeClr val="tx2"/>
+                </a:solidFill>
+                <a:latin typeface="Crimson Pro" pitchFamily="34" charset="0"/>
+                <a:ea typeface="Crimson Pro" pitchFamily="34" charset="-122"/>
+                <a:cs typeface="Crimson Pro" pitchFamily="34" charset="-120"/>
               </a:rPr>
               <a:t>Cada semana, las alumnas comparten sus wins</a:t>
             </a:r>
-            <a:endParaRPr lang="en-US" sz="3200" dirty="0"/>
-          </a:p>
-        </p:txBody>
+            <a:endParaRPr lang="en-US" sz="3600" dirty="0"/>
+          </a:p>
+        </p:txBody>
+      </p:sp>
+      <p:sp>
+        <p:nvSpPr>
+          <p:cNvPr id="4" name="marco1"/>
+          <p:cNvSpPr/>
+          <p:nvPr/>
+        </p:nvSpPr>
+        <p:spPr>
+          <a:xfrm>
+            <a:off x="621792" y="2542032"/>
+            <a:ext cx="3511296" cy="1957548"/>
+          </a:xfrm>
+          <a:prstGeom prst="roundRect">
+            <a:avLst>
+              <a:gd name="adj" fmla="val 8408"/>
+            </a:avLst>
+          </a:prstGeom>
+          <a:solidFill>
+            <a:schemeClr val="bg2"/>
+          </a:solidFill>
+          <a:ln w="12700">
+            <a:solidFill>
+              <a:schemeClr val="accent2"/>
+            </a:solidFill>
+            <a:prstDash val="solid"/>
+          </a:ln>
+        </p:spPr>
       </p:sp>
       <p:pic>
         <p:nvPicPr>
-          <p:cNvPr id="4" name="captura1" descr="Captura de un win en la comunidad">    </p:cNvPr>
+          <p:cNvPr id="5" name="captura1" descr="Captura de un win en la comunidad">    </p:cNvPr>
           <p:cNvPicPr>
             <a:picLocks noChangeAspect="1"/>
           </p:cNvPicPr>
@@ -7419,16 +7707,43 @@
         <p:spPr>
           <a:xfrm>
             <a:off x="731520" y="2651760"/>
-            <a:ext cx="3429000" cy="1810512"/>
+            <a:ext cx="3291840" cy="1738092"/>
           </a:xfrm>
           <a:prstGeom prst="rect">
             <a:avLst/>
           </a:prstGeom>
         </p:spPr>
       </p:pic>
+      <p:sp>
+        <p:nvSpPr>
+          <p:cNvPr id="6" name="marco2"/>
+          <p:cNvSpPr/>
+          <p:nvPr/>
+        </p:nvSpPr>
+        <p:spPr>
+          <a:xfrm>
+            <a:off x="4325112" y="2542032"/>
+            <a:ext cx="3511296" cy="1536192"/>
+          </a:xfrm>
+          <a:prstGeom prst="roundRect">
+            <a:avLst>
+              <a:gd name="adj" fmla="val 10714"/>
+            </a:avLst>
+          </a:prstGeom>
+          <a:solidFill>
+            <a:schemeClr val="bg2"/>
+          </a:solidFill>
+          <a:ln w="12700">
+            <a:solidFill>
+              <a:schemeClr val="accent2"/>
+            </a:solidFill>
+            <a:prstDash val="solid"/>
+          </a:ln>
+        </p:spPr>
+      </p:sp>
       <p:pic>
         <p:nvPicPr>
-          <p:cNvPr id="5" name="captura2" descr="Captura de un win en la comunidad">    </p:cNvPr>
+          <p:cNvPr id="7" name="captura2" descr="Captura de un win en la comunidad">    </p:cNvPr>
           <p:cNvPicPr>
             <a:picLocks noChangeAspect="1"/>
           </p:cNvPicPr>
@@ -7442,17 +7757,44 @@
         </p:blipFill>
         <p:spPr>
           <a:xfrm>
-            <a:off x="4366260" y="2651760"/>
-            <a:ext cx="3429000" cy="1371600"/>
+            <a:off x="4434840" y="2651760"/>
+            <a:ext cx="3291840" cy="1316736"/>
           </a:xfrm>
           <a:prstGeom prst="rect">
             <a:avLst/>
           </a:prstGeom>
         </p:spPr>
       </p:pic>
+      <p:sp>
+        <p:nvSpPr>
+          <p:cNvPr id="8" name="marco3"/>
+          <p:cNvSpPr/>
+          <p:nvPr/>
+        </p:nvSpPr>
+        <p:spPr>
+          <a:xfrm>
+            <a:off x="8028432" y="2542032"/>
+            <a:ext cx="3511296" cy="1684325"/>
+          </a:xfrm>
+          <a:prstGeom prst="roundRect">
+            <a:avLst>
+              <a:gd name="adj" fmla="val 9772"/>
+            </a:avLst>
+          </a:prstGeom>
+          <a:solidFill>
+            <a:schemeClr val="bg2"/>
+          </a:solidFill>
+          <a:ln w="12700">
+            <a:solidFill>
+              <a:schemeClr val="accent2"/>
+            </a:solidFill>
+            <a:prstDash val="solid"/>
+          </a:ln>
+        </p:spPr>
+      </p:sp>
       <p:pic>
         <p:nvPicPr>
-          <p:cNvPr id="6" name="captura3" descr="Captura de un win en la comunidad">    </p:cNvPr>
+          <p:cNvPr id="9" name="captura3" descr="Captura de un win en la comunidad">    </p:cNvPr>
           <p:cNvPicPr>
             <a:picLocks noChangeAspect="1"/>
           </p:cNvPicPr>
@@ -7466,8 +7808,8 @@
         </p:blipFill>
         <p:spPr>
           <a:xfrm>
-            <a:off x="8001000" y="2651760"/>
-            <a:ext cx="3429000" cy="1525905"/>
+            <a:off x="8138160" y="2651760"/>
+            <a:ext cx="3291840" cy="1464869"/>
           </a:xfrm>
           <a:prstGeom prst="rect">
             <a:avLst/>
@@ -7504,7 +7846,7 @@
             <a:lvl1pPr>
               <a:defRPr sz="1100">
                 <a:solidFill>
-                  <a:schemeClr val="bg2"/>
+                  <a:schemeClr val="accent5"/>
                 </a:solidFill>
               </a:defRPr>
             </a:lvl1pPr>
@@ -7571,14 +7913,14 @@
               <a:buNone/>
             </a:pPr>
             <a:r>
-              <a:rPr lang="en-US" sz="1600" b="1" spc="300" kern="0" dirty="0">
+              <a:rPr lang="en-US" sz="1500" b="1" spc="300" kern="0" dirty="0">
                 <a:solidFill>
                   <a:schemeClr val="accent1"/>
                 </a:solidFill>
               </a:rPr>
               <a:t>11 · CIERRE</a:t>
             </a:r>
-            <a:endParaRPr lang="en-US" sz="1600" dirty="0"/>
+            <a:endParaRPr lang="en-US" sz="1500" dirty="0"/>
           </a:p>
         </p:txBody>
       </p:sp>
@@ -7605,42 +7947,42 @@
           <a:p>
             <a:pPr indent="0" marL="0">
               <a:lnSpc>
-                <a:spcPct val="105000"/>
+                <a:spcPct val="100000"/>
               </a:lnSpc>
               <a:buNone/>
             </a:pPr>
             <a:r>
-              <a:rPr lang="en-US" sz="4400" b="1" dirty="0">
+              <a:rPr lang="en-US" sz="5000" b="1" dirty="0">
                 <a:solidFill>
                   <a:schemeClr val="bg1"/>
                 </a:solidFill>
-                <a:latin typeface="Cambria" pitchFamily="34" charset="0"/>
-                <a:ea typeface="Cambria" pitchFamily="34" charset="-122"/>
-                <a:cs typeface="Cambria" pitchFamily="34" charset="-120"/>
+                <a:latin typeface="Crimson Pro" pitchFamily="34" charset="0"/>
+                <a:ea typeface="Crimson Pro" pitchFamily="34" charset="-122"/>
+                <a:cs typeface="Crimson Pro" pitchFamily="34" charset="-120"/>
               </a:rPr>
               <a:t>Quizás profesionalmente ya lo estás.</a:t>
             </a:r>
-            <a:endParaRPr lang="en-US" sz="4400" dirty="0"/>
+            <a:endParaRPr lang="en-US" sz="5000" dirty="0"/>
           </a:p>
           <a:p>
             <a:pPr indent="0" marL="0">
               <a:lnSpc>
-                <a:spcPct val="105000"/>
+                <a:spcPct val="100000"/>
               </a:lnSpc>
               <a:buNone/>
             </a:pPr>
             <a:r>
-              <a:rPr lang="en-US" sz="4400" b="1" dirty="0">
+              <a:rPr lang="en-US" sz="5000" b="1" i="1" dirty="0">
                 <a:solidFill>
                   <a:schemeClr val="accent1"/>
                 </a:solidFill>
-                <a:latin typeface="Cambria" pitchFamily="34" charset="0"/>
-                <a:ea typeface="Cambria" pitchFamily="34" charset="-122"/>
-                <a:cs typeface="Cambria" pitchFamily="34" charset="-120"/>
+                <a:latin typeface="Crimson Pro" pitchFamily="34" charset="0"/>
+                <a:ea typeface="Crimson Pro" pitchFamily="34" charset="-122"/>
+                <a:cs typeface="Crimson Pro" pitchFamily="34" charset="-120"/>
               </a:rPr>
               <a:t>Lo que falta es poder mostrarlo en inglés.</a:t>
             </a:r>
-            <a:endParaRPr lang="en-US" sz="4400" dirty="0"/>
+            <a:endParaRPr lang="en-US" sz="5000" dirty="0"/>
           </a:p>
         </p:txBody>
       </p:sp>
@@ -7741,14 +8083,14 @@
               <a:buNone/>
             </a:pPr>
             <a:r>
-              <a:rPr lang="en-US" sz="1600" b="1" spc="300" kern="0" dirty="0">
-                <a:solidFill>
-                  <a:schemeClr val="accent1"/>
+              <a:rPr lang="en-US" sz="1500" b="1" spc="300" kern="0" dirty="0">
+                <a:solidFill>
+                  <a:schemeClr val="accent2"/>
                 </a:solidFill>
               </a:rPr>
               <a:t>11 · ¿ES PARA VOS?</a:t>
             </a:r>
-            <a:endParaRPr lang="en-US" sz="1600" dirty="0"/>
+            <a:endParaRPr lang="en-US" sz="1500" dirty="0"/>
           </a:p>
         </p:txBody>
       </p:sp>
@@ -7777,14 +8119,14 @@
               <a:buNone/>
             </a:pPr>
             <a:r>
-              <a:rPr lang="en-US" sz="1600" b="1" spc="300" kern="0" dirty="0">
-                <a:solidFill>
-                  <a:schemeClr val="bg2"/>
+              <a:rPr lang="en-US" sz="1500" b="1" spc="300" kern="0" dirty="0">
+                <a:solidFill>
+                  <a:schemeClr val="accent2"/>
                 </a:solidFill>
               </a:rPr>
               <a:t>ES PARA VOS SI</a:t>
             </a:r>
-            <a:endParaRPr lang="en-US" sz="1600" dirty="0"/>
+            <a:endParaRPr lang="en-US" sz="1500" dirty="0"/>
           </a:p>
         </p:txBody>
       </p:sp>
@@ -7816,14 +8158,14 @@
               <a:buNone/>
             </a:pPr>
             <a:r>
-              <a:rPr lang="en-US" sz="2400" dirty="0">
-                <a:solidFill>
-                  <a:schemeClr val="bg1"/>
+              <a:rPr lang="en-US" sz="2200" dirty="0">
+                <a:solidFill>
+                  <a:schemeClr val="tx1"/>
                 </a:solidFill>
               </a:rPr>
               <a:t>✓  Tenés un nivel intermedio o intermedio alto</a:t>
             </a:r>
-            <a:endParaRPr lang="en-US" sz="2400" dirty="0"/>
+            <a:endParaRPr lang="en-US" sz="2200" dirty="0"/>
           </a:p>
           <a:p>
             <a:pPr indent="0" marL="0">
@@ -7833,14 +8175,14 @@
               <a:buNone/>
             </a:pPr>
             <a:r>
-              <a:rPr lang="en-US" sz="2400" dirty="0">
-                <a:solidFill>
-                  <a:schemeClr val="bg1"/>
+              <a:rPr lang="en-US" sz="2200" dirty="0">
+                <a:solidFill>
+                  <a:schemeClr val="tx1"/>
                 </a:solidFill>
               </a:rPr>
               <a:t>✓  Ya trabajás en inglés</a:t>
             </a:r>
-            <a:endParaRPr lang="en-US" sz="2400" dirty="0"/>
+            <a:endParaRPr lang="en-US" sz="2200" dirty="0"/>
           </a:p>
           <a:p>
             <a:pPr indent="0" marL="0">
@@ -7850,14 +8192,14 @@
               <a:buNone/>
             </a:pPr>
             <a:r>
-              <a:rPr lang="en-US" sz="2400" dirty="0">
-                <a:solidFill>
-                  <a:schemeClr val="bg1"/>
+              <a:rPr lang="en-US" sz="2200" dirty="0">
+                <a:solidFill>
+                  <a:schemeClr val="tx1"/>
                 </a:solidFill>
               </a:rPr>
               <a:t>✓  O estás preparando una entrevista en inglés</a:t>
             </a:r>
-            <a:endParaRPr lang="en-US" sz="2400" dirty="0"/>
+            <a:endParaRPr lang="en-US" sz="2200" dirty="0"/>
           </a:p>
         </p:txBody>
       </p:sp>
@@ -7886,14 +8228,14 @@
               <a:buNone/>
             </a:pPr>
             <a:r>
-              <a:rPr lang="en-US" sz="1600" b="1" spc="300" kern="0" dirty="0">
-                <a:solidFill>
-                  <a:schemeClr val="bg2"/>
+              <a:rPr lang="en-US" sz="1500" b="1" spc="300" kern="0" dirty="0">
+                <a:solidFill>
+                  <a:schemeClr val="accent2"/>
                 </a:solidFill>
               </a:rPr>
               <a:t>NO ES PARA VOS SI</a:t>
             </a:r>
-            <a:endParaRPr lang="en-US" sz="1600" dirty="0"/>
+            <a:endParaRPr lang="en-US" sz="1500" dirty="0"/>
           </a:p>
         </p:txBody>
       </p:sp>
@@ -7925,14 +8267,14 @@
               <a:buNone/>
             </a:pPr>
             <a:r>
-              <a:rPr lang="en-US" sz="2400" dirty="0">
-                <a:solidFill>
-                  <a:schemeClr val="bg2"/>
+              <a:rPr lang="en-US" sz="2200" dirty="0">
+                <a:solidFill>
+                  <a:schemeClr val="accent5"/>
                 </a:solidFill>
               </a:rPr>
               <a:t>✕  Empezás desde cero</a:t>
             </a:r>
-            <a:endParaRPr lang="en-US" sz="2400" dirty="0"/>
+            <a:endParaRPr lang="en-US" sz="2200" dirty="0"/>
           </a:p>
           <a:p>
             <a:pPr indent="0" marL="0">
@@ -7942,14 +8284,14 @@
               <a:buNone/>
             </a:pPr>
             <a:r>
-              <a:rPr lang="en-US" sz="2400" dirty="0">
-                <a:solidFill>
-                  <a:schemeClr val="bg2"/>
+              <a:rPr lang="en-US" sz="2200" dirty="0">
+                <a:solidFill>
+                  <a:schemeClr val="accent5"/>
                 </a:solidFill>
               </a:rPr>
               <a:t>✕  Querés preparar un examen</a:t>
             </a:r>
-            <a:endParaRPr lang="en-US" sz="2400" dirty="0"/>
+            <a:endParaRPr lang="en-US" sz="2200" dirty="0"/>
           </a:p>
           <a:p>
             <a:pPr indent="0" marL="0">
@@ -7959,14 +8301,14 @@
               <a:buNone/>
             </a:pPr>
             <a:r>
-              <a:rPr lang="en-US" sz="2400" dirty="0">
-                <a:solidFill>
-                  <a:schemeClr val="bg2"/>
+              <a:rPr lang="en-US" sz="2200" dirty="0">
+                <a:solidFill>
+                  <a:schemeClr val="accent5"/>
                 </a:solidFill>
               </a:rPr>
               <a:t>✕  Buscás memorizar respuestas</a:t>
             </a:r>
-            <a:endParaRPr lang="en-US" sz="2400" dirty="0"/>
+            <a:endParaRPr lang="en-US" sz="2200" dirty="0"/>
           </a:p>
         </p:txBody>
       </p:sp>
@@ -8000,7 +8342,7 @@
             <a:lvl1pPr>
               <a:defRPr sz="1100">
                 <a:solidFill>
-                  <a:schemeClr val="bg2"/>
+                  <a:schemeClr val="accent5"/>
                 </a:solidFill>
               </a:defRPr>
             </a:lvl1pPr>
@@ -8067,14 +8409,14 @@
               <a:buNone/>
             </a:pPr>
             <a:r>
-              <a:rPr lang="en-US" sz="1600" b="1" spc="300" kern="0" dirty="0">
+              <a:rPr lang="en-US" sz="1500" b="1" spc="300" kern="0" dirty="0">
                 <a:solidFill>
                   <a:schemeClr val="accent1"/>
                 </a:solidFill>
               </a:rPr>
               <a:t>11 · CUPOS</a:t>
             </a:r>
-            <a:endParaRPr lang="en-US" sz="1600" dirty="0"/>
+            <a:endParaRPr lang="en-US" sz="1500" dirty="0"/>
           </a:p>
         </p:txBody>
       </p:sp>
@@ -8103,13 +8445,13 @@
               <a:buNone/>
             </a:pPr>
             <a:r>
-              <a:rPr lang="en-US" sz="9600" b="1" dirty="0">
+              <a:rPr lang="en-US" sz="11000" b="1" dirty="0">
                 <a:solidFill>
                   <a:schemeClr val="bg1"/>
                 </a:solidFill>
-                <a:latin typeface="Cambria" pitchFamily="34" charset="0"/>
-                <a:ea typeface="Cambria" pitchFamily="34" charset="-122"/>
-                <a:cs typeface="Cambria" pitchFamily="34" charset="-120"/>
+                <a:latin typeface="Crimson Pro" pitchFamily="34" charset="0"/>
+                <a:ea typeface="Crimson Pro" pitchFamily="34" charset="-122"/>
+                <a:cs typeface="Crimson Pro" pitchFamily="34" charset="-120"/>
               </a:rPr>
               <a:t>Hasta </a:t>
             </a:r>
@@ -8117,17 +8459,17 @@
               <a:buNone/>
             </a:pPr>
             <a:r>
-              <a:rPr lang="en-US" sz="9600" b="1" dirty="0">
+              <a:rPr lang="en-US" sz="11000" b="1" i="1" dirty="0">
                 <a:solidFill>
                   <a:schemeClr val="accent1"/>
                 </a:solidFill>
-                <a:latin typeface="Cambria" pitchFamily="34" charset="0"/>
-                <a:ea typeface="Cambria" pitchFamily="34" charset="-122"/>
-                <a:cs typeface="Cambria" pitchFamily="34" charset="-120"/>
+                <a:latin typeface="Crimson Pro" pitchFamily="34" charset="0"/>
+                <a:ea typeface="Crimson Pro" pitchFamily="34" charset="-122"/>
+                <a:cs typeface="Crimson Pro" pitchFamily="34" charset="-120"/>
               </a:rPr>
               <a:t>20</a:t>
             </a:r>
-            <a:endParaRPr lang="en-US" sz="9600" dirty="0"/>
+            <a:endParaRPr lang="en-US" sz="11000" dirty="0"/>
           </a:p>
         </p:txBody>
       </p:sp>
@@ -8156,14 +8498,14 @@
               <a:buNone/>
             </a:pPr>
             <a:r>
-              <a:rPr lang="en-US" sz="2200" dirty="0">
+              <a:rPr lang="en-US" sz="2000" dirty="0">
                 <a:solidFill>
                   <a:schemeClr val="bg2"/>
                 </a:solidFill>
               </a:rPr>
               <a:t>alumnas activas al mismo tiempo. Cada proceso se arma con el material real de cada una.</a:t>
             </a:r>
-            <a:endParaRPr lang="en-US" sz="2200" dirty="0"/>
+            <a:endParaRPr lang="en-US" sz="2000" dirty="0"/>
           </a:p>
         </p:txBody>
       </p:sp>
@@ -8264,14 +8606,14 @@
               <a:buNone/>
             </a:pPr>
             <a:r>
-              <a:rPr lang="en-US" sz="1600" b="1" spc="300" kern="0" dirty="0">
+              <a:rPr lang="en-US" sz="1500" b="1" spc="300" kern="0" dirty="0">
                 <a:solidFill>
                   <a:schemeClr val="accent1"/>
                 </a:solidFill>
               </a:rPr>
               <a:t>ESCRIBIME POR MENSAJE DIRECTO EN INSTAGRAM</a:t>
             </a:r>
-            <a:endParaRPr lang="en-US" sz="1600" dirty="0"/>
+            <a:endParaRPr lang="en-US" sz="1500" dirty="0"/>
           </a:p>
         </p:txBody>
       </p:sp>
@@ -8283,7 +8625,7 @@
         </p:nvSpPr>
         <p:spPr>
           <a:xfrm>
-            <a:off x="731520" y="2011680"/>
+            <a:off x="731520" y="1920240"/>
             <a:ext cx="10698480" cy="1828800"/>
           </a:xfrm>
           <a:prstGeom prst="rect">
@@ -8300,17 +8642,17 @@
               <a:buNone/>
             </a:pPr>
             <a:r>
-              <a:rPr lang="en-US" sz="12000" b="1" spc="600" kern="0" dirty="0">
+              <a:rPr lang="en-US" sz="13000" b="1" spc="600" kern="0" dirty="0">
                 <a:solidFill>
                   <a:schemeClr val="accent1"/>
                 </a:solidFill>
-                <a:latin typeface="Calibri" pitchFamily="34" charset="0"/>
-                <a:ea typeface="Calibri" pitchFamily="34" charset="-122"/>
-                <a:cs typeface="Calibri" pitchFamily="34" charset="-120"/>
+                <a:latin typeface="Crimson Pro" pitchFamily="34" charset="0"/>
+                <a:ea typeface="Crimson Pro" pitchFamily="34" charset="-122"/>
+                <a:cs typeface="Crimson Pro" pitchFamily="34" charset="-120"/>
               </a:rPr>
               <a:t>READY</a:t>
             </a:r>
-            <a:endParaRPr lang="en-US" sz="12000" dirty="0"/>
+            <a:endParaRPr lang="en-US" sz="13000" dirty="0"/>
           </a:p>
         </p:txBody>
       </p:sp>
@@ -8339,14 +8681,14 @@
               <a:buNone/>
             </a:pPr>
             <a:r>
-              <a:rPr lang="en-US" sz="3600" dirty="0">
+              <a:rPr lang="en-US" sz="3200" dirty="0">
                 <a:solidFill>
                   <a:schemeClr val="bg1"/>
                 </a:solidFill>
               </a:rPr>
               <a:t>@breakingbarriers.atwork</a:t>
             </a:r>
-            <a:endParaRPr lang="en-US" sz="3600" dirty="0"/>
+            <a:endParaRPr lang="en-US" sz="3200" dirty="0"/>
           </a:p>
         </p:txBody>
       </p:sp>
@@ -8447,14 +8789,14 @@
               <a:buNone/>
             </a:pPr>
             <a:r>
-              <a:rPr lang="en-US" sz="1600" b="1" spc="300" kern="0" dirty="0">
-                <a:solidFill>
-                  <a:schemeClr val="accent1"/>
+              <a:rPr lang="en-US" sz="1500" b="1" spc="300" kern="0" dirty="0">
+                <a:solidFill>
+                  <a:schemeClr val="accent2"/>
                 </a:solidFill>
               </a:rPr>
               <a:t>2 · PARA QUIÉN ES ESTE VIDEO</a:t>
             </a:r>
-            <a:endParaRPr lang="en-US" sz="1600" dirty="0"/>
+            <a:endParaRPr lang="en-US" sz="1500" dirty="0"/>
           </a:p>
         </p:txBody>
       </p:sp>
@@ -8481,39 +8823,39 @@
           <a:p>
             <a:pPr indent="0" marL="0">
               <a:lnSpc>
-                <a:spcPct val="105000"/>
+                <a:spcPct val="100000"/>
               </a:lnSpc>
               <a:buNone/>
             </a:pPr>
             <a:r>
-              <a:rPr lang="en-US" sz="5000" b="1" dirty="0">
-                <a:solidFill>
-                  <a:schemeClr val="bg1"/>
-                </a:solidFill>
-                <a:latin typeface="Cambria" pitchFamily="34" charset="0"/>
-                <a:ea typeface="Cambria" pitchFamily="34" charset="-122"/>
-                <a:cs typeface="Cambria" pitchFamily="34" charset="-120"/>
+              <a:rPr lang="en-US" sz="5800" b="1" dirty="0">
+                <a:solidFill>
+                  <a:schemeClr val="tx1"/>
+                </a:solidFill>
+                <a:latin typeface="Crimson Pro" pitchFamily="34" charset="0"/>
+                <a:ea typeface="Crimson Pro" pitchFamily="34" charset="-122"/>
+                <a:cs typeface="Crimson Pro" pitchFamily="34" charset="-120"/>
               </a:rPr>
               <a:t>Quizás profesionalmente </a:t>
             </a:r>
             <a:pPr indent="0" marL="0">
               <a:lnSpc>
-                <a:spcPct val="105000"/>
+                <a:spcPct val="100000"/>
               </a:lnSpc>
               <a:buNone/>
             </a:pPr>
             <a:r>
-              <a:rPr lang="en-US" sz="5000" b="1" dirty="0">
-                <a:solidFill>
-                  <a:schemeClr val="accent1"/>
-                </a:solidFill>
-                <a:latin typeface="Cambria" pitchFamily="34" charset="0"/>
-                <a:ea typeface="Cambria" pitchFamily="34" charset="-122"/>
-                <a:cs typeface="Cambria" pitchFamily="34" charset="-120"/>
+              <a:rPr lang="en-US" sz="5800" b="1" i="1" dirty="0">
+                <a:solidFill>
+                  <a:schemeClr val="tx2"/>
+                </a:solidFill>
+                <a:latin typeface="Crimson Pro" pitchFamily="34" charset="0"/>
+                <a:ea typeface="Crimson Pro" pitchFamily="34" charset="-122"/>
+                <a:cs typeface="Crimson Pro" pitchFamily="34" charset="-120"/>
               </a:rPr>
               <a:t>ya estás preparada.</a:t>
             </a:r>
-            <a:endParaRPr lang="en-US" sz="5000" dirty="0"/>
+            <a:endParaRPr lang="en-US" sz="5800" dirty="0"/>
           </a:p>
         </p:txBody>
       </p:sp>
@@ -8525,7 +8867,7 @@
         </p:nvSpPr>
         <p:spPr>
           <a:xfrm>
-            <a:off x="731520" y="3840480"/>
+            <a:off x="731520" y="3931920"/>
             <a:ext cx="10058400" cy="914400"/>
           </a:xfrm>
           <a:prstGeom prst="rect">
@@ -8542,14 +8884,14 @@
               <a:buNone/>
             </a:pPr>
             <a:r>
-              <a:rPr lang="en-US" sz="2200" dirty="0">
-                <a:solidFill>
-                  <a:schemeClr val="bg2"/>
+              <a:rPr lang="en-US" sz="2000" dirty="0">
+                <a:solidFill>
+                  <a:schemeClr val="accent5"/>
                 </a:solidFill>
               </a:rPr>
               <a:t>Lo que falta es que eso también se vea cuando hablás en inglés.</a:t>
             </a:r>
-            <a:endParaRPr lang="en-US" sz="2200" dirty="0"/>
+            <a:endParaRPr lang="en-US" sz="2000" dirty="0"/>
           </a:p>
         </p:txBody>
       </p:sp>
@@ -8583,7 +8925,7 @@
             <a:lvl1pPr>
               <a:defRPr sz="1100">
                 <a:solidFill>
-                  <a:schemeClr val="bg2"/>
+                  <a:schemeClr val="accent5"/>
                 </a:solidFill>
               </a:defRPr>
             </a:lvl1pPr>
@@ -8650,14 +8992,14 @@
               <a:buNone/>
             </a:pPr>
             <a:r>
-              <a:rPr lang="en-US" sz="1600" b="1" spc="300" kern="0" dirty="0">
+              <a:rPr lang="en-US" sz="1500" b="1" spc="300" kern="0" dirty="0">
                 <a:solidFill>
                   <a:schemeClr val="accent1"/>
                 </a:solidFill>
               </a:rPr>
               <a:t>3 · LO VEO TODO EL TIEMPO</a:t>
             </a:r>
-            <a:endParaRPr lang="en-US" sz="1600" dirty="0"/>
+            <a:endParaRPr lang="en-US" sz="1500" dirty="0"/>
           </a:p>
         </p:txBody>
       </p:sp>
@@ -8686,17 +9028,17 @@
               <a:buNone/>
             </a:pPr>
             <a:r>
-              <a:rPr lang="en-US" sz="4600" i="1" dirty="0">
+              <a:rPr lang="en-US" sz="5200" i="1" dirty="0">
                 <a:solidFill>
                   <a:schemeClr val="bg1"/>
                 </a:solidFill>
-                <a:latin typeface="Cambria" pitchFamily="34" charset="0"/>
-                <a:ea typeface="Cambria" pitchFamily="34" charset="-122"/>
-                <a:cs typeface="Cambria" pitchFamily="34" charset="-120"/>
+                <a:latin typeface="Crimson Pro" pitchFamily="34" charset="0"/>
+                <a:ea typeface="Crimson Pro" pitchFamily="34" charset="-122"/>
+                <a:cs typeface="Crimson Pro" pitchFamily="34" charset="-120"/>
               </a:rPr>
               <a:t>“Not perfect, but the message was delivered.”</a:t>
             </a:r>
-            <a:endParaRPr lang="en-US" sz="4600" dirty="0"/>
+            <a:endParaRPr lang="en-US" sz="5200" dirty="0"/>
           </a:p>
         </p:txBody>
       </p:sp>
@@ -8708,7 +9050,7 @@
         </p:nvSpPr>
         <p:spPr>
           <a:xfrm>
-            <a:off x="731520" y="4023360"/>
+            <a:off x="731520" y="3657600"/>
             <a:ext cx="10058400" cy="457200"/>
           </a:xfrm>
           <a:prstGeom prst="rect">
@@ -8725,7 +9067,7 @@
               <a:buNone/>
             </a:pPr>
             <a:r>
-              <a:rPr lang="en-US" sz="2000" b="1" dirty="0">
+              <a:rPr lang="en-US" sz="1900" b="1" dirty="0">
                 <a:solidFill>
                   <a:schemeClr val="bg1"/>
                 </a:solidFill>
@@ -8736,14 +9078,14 @@
               <a:buNone/>
             </a:pPr>
             <a:r>
-              <a:rPr lang="en-US" sz="2000" dirty="0">
+              <a:rPr lang="en-US" sz="1900" dirty="0">
                 <a:solidFill>
                   <a:schemeClr val="bg2"/>
                 </a:solidFill>
               </a:rPr>
               <a:t> · Senior Manager de IT</a:t>
             </a:r>
-            <a:endParaRPr lang="en-US" sz="2000" dirty="0"/>
+            <a:endParaRPr lang="en-US" sz="1900" dirty="0"/>
           </a:p>
         </p:txBody>
       </p:sp>
@@ -8844,14 +9186,14 @@
               <a:buNone/>
             </a:pPr>
             <a:r>
-              <a:rPr lang="en-US" sz="1600" b="1" spc="300" kern="0" dirty="0">
+              <a:rPr lang="en-US" sz="1500" b="1" spc="300" kern="0" dirty="0">
                 <a:solidFill>
                   <a:schemeClr val="accent1"/>
                 </a:solidFill>
               </a:rPr>
               <a:t>3 · LO VEO TODO EL TIEMPO</a:t>
             </a:r>
-            <a:endParaRPr lang="en-US" sz="1600" dirty="0"/>
+            <a:endParaRPr lang="en-US" sz="1500" dirty="0"/>
           </a:p>
         </p:txBody>
       </p:sp>
@@ -8880,17 +9222,17 @@
               <a:buNone/>
             </a:pPr>
             <a:r>
-              <a:rPr lang="en-US" sz="4000" i="1" dirty="0">
+              <a:rPr lang="en-US" sz="4600" i="1" dirty="0">
                 <a:solidFill>
                   <a:schemeClr val="bg1"/>
                 </a:solidFill>
-                <a:latin typeface="Cambria" pitchFamily="34" charset="0"/>
-                <a:ea typeface="Cambria" pitchFamily="34" charset="-122"/>
-                <a:cs typeface="Cambria" pitchFamily="34" charset="-120"/>
+                <a:latin typeface="Crimson Pro" pitchFamily="34" charset="0"/>
+                <a:ea typeface="Crimson Pro" pitchFamily="34" charset="-122"/>
+                <a:cs typeface="Crimson Pro" pitchFamily="34" charset="-120"/>
               </a:rPr>
               <a:t>“Ya no pienso tanto al querer transmitir una idea, simplemente confío y la menciono.”</a:t>
             </a:r>
-            <a:endParaRPr lang="en-US" sz="4000" dirty="0"/>
+            <a:endParaRPr lang="en-US" sz="4600" dirty="0"/>
           </a:p>
         </p:txBody>
       </p:sp>
@@ -8919,7 +9261,7 @@
               <a:buNone/>
             </a:pPr>
             <a:r>
-              <a:rPr lang="en-US" sz="2000" b="1" dirty="0">
+              <a:rPr lang="en-US" sz="1900" b="1" dirty="0">
                 <a:solidFill>
                   <a:schemeClr val="bg1"/>
                 </a:solidFill>
@@ -8930,14 +9272,14 @@
               <a:buNone/>
             </a:pPr>
             <a:r>
-              <a:rPr lang="en-US" sz="2000" dirty="0">
+              <a:rPr lang="en-US" sz="1900" dirty="0">
                 <a:solidFill>
                   <a:schemeClr val="bg2"/>
                 </a:solidFill>
               </a:rPr>
               <a:t> · Líder de equipo de QA</a:t>
             </a:r>
-            <a:endParaRPr lang="en-US" sz="2000" dirty="0"/>
+            <a:endParaRPr lang="en-US" sz="1900" dirty="0"/>
           </a:p>
         </p:txBody>
       </p:sp>
@@ -9038,20 +9380,47 @@
               <a:buNone/>
             </a:pPr>
             <a:r>
-              <a:rPr lang="en-US" sz="1600" b="1" spc="300" kern="0" dirty="0">
-                <a:solidFill>
-                  <a:schemeClr val="accent1"/>
+              <a:rPr lang="en-US" sz="1500" b="1" spc="300" kern="0" dirty="0">
+                <a:solidFill>
+                  <a:schemeClr val="accent2"/>
                 </a:solidFill>
               </a:rPr>
               <a:t>3 · LO VEO TODO EL TIEMPO</a:t>
             </a:r>
-            <a:endParaRPr lang="en-US" sz="1600" dirty="0"/>
-          </a:p>
-        </p:txBody>
+            <a:endParaRPr lang="en-US" sz="1500" dirty="0"/>
+          </a:p>
+        </p:txBody>
+      </p:sp>
+      <p:sp>
+        <p:nvSpPr>
+          <p:cNvPr id="3" name="marco"/>
+          <p:cNvSpPr/>
+          <p:nvPr/>
+        </p:nvSpPr>
+        <p:spPr>
+          <a:xfrm>
+            <a:off x="5440680" y="2190902"/>
+            <a:ext cx="6181344" cy="3664915"/>
+          </a:xfrm>
+          <a:prstGeom prst="roundRect">
+            <a:avLst>
+              <a:gd name="adj" fmla="val 4990"/>
+            </a:avLst>
+          </a:prstGeom>
+          <a:solidFill>
+            <a:schemeClr val="bg2"/>
+          </a:solidFill>
+          <a:ln w="12700">
+            <a:solidFill>
+              <a:schemeClr val="accent2"/>
+            </a:solidFill>
+            <a:prstDash val="solid"/>
+          </a:ln>
+        </p:spPr>
       </p:sp>
       <p:pic>
         <p:nvPicPr>
-          <p:cNvPr id="3" name="captura" descr="Captura del mensaje de Virginia en la comunidad">    </p:cNvPr>
+          <p:cNvPr id="4" name="captura" descr="Captura del mensaje de Virginia en la comunidad">    </p:cNvPr>
           <p:cNvPicPr>
             <a:picLocks noChangeAspect="1"/>
           </p:cNvPicPr>
@@ -9065,53 +9434,14 @@
         </p:blipFill>
         <p:spPr>
           <a:xfrm>
-            <a:off x="5788152" y="2407615"/>
-            <a:ext cx="5669280" cy="3231490"/>
+            <a:off x="5605272" y="2355494"/>
+            <a:ext cx="5852160" cy="3335731"/>
           </a:xfrm>
           <a:prstGeom prst="rect">
             <a:avLst/>
           </a:prstGeom>
         </p:spPr>
       </p:pic>
-      <p:sp>
-        <p:nvSpPr>
-          <p:cNvPr id="4" name="Text 1"/>
-          <p:cNvSpPr txBox="1"/>
-          <p:nvPr/>
-        </p:nvSpPr>
-        <p:spPr>
-          <a:xfrm>
-            <a:off x="731520" y="2194560"/>
-            <a:ext cx="4507992" cy="914400"/>
-          </a:xfrm>
-          <a:prstGeom prst="rect">
-            <a:avLst/>
-          </a:prstGeom>
-          <a:noFill/>
-          <a:ln/>
-        </p:spPr>
-        <p:txBody>
-          <a:bodyPr wrap="square" lIns="0" tIns="0" rIns="0" bIns="0" rtlCol="0" anchor="t"/>
-          <a:lstStyle/>
-          <a:p>
-            <a:pPr indent="0" marL="0">
-              <a:buNone/>
-            </a:pPr>
-            <a:r>
-              <a:rPr lang="en-US" sz="4000" b="1" dirty="0">
-                <a:solidFill>
-                  <a:schemeClr val="bg1"/>
-                </a:solidFill>
-                <a:latin typeface="Cambria" pitchFamily="34" charset="0"/>
-                <a:ea typeface="Cambria" pitchFamily="34" charset="-122"/>
-                <a:cs typeface="Cambria" pitchFamily="34" charset="-120"/>
-              </a:rPr>
-              <a:t>Virginia</a:t>
-            </a:r>
-            <a:endParaRPr lang="en-US" sz="4000" dirty="0"/>
-          </a:p>
-        </p:txBody>
-      </p:sp>
       <p:sp>
         <p:nvSpPr>
           <p:cNvPr id="5" name="Text 2"/>
@@ -9120,8 +9450,8 @@
         </p:nvSpPr>
         <p:spPr>
           <a:xfrm>
-            <a:off x="731520" y="3200400"/>
-            <a:ext cx="4507992" cy="2011680"/>
+            <a:off x="731520" y="2103120"/>
+            <a:ext cx="4233672" cy="1463040"/>
           </a:xfrm>
           <a:prstGeom prst="rect">
             <a:avLst/>
@@ -9137,9 +9467,48 @@
               <a:buNone/>
             </a:pPr>
             <a:r>
+              <a:rPr lang="en-US" sz="4800" b="1" dirty="0">
+                <a:solidFill>
+                  <a:schemeClr val="tx2"/>
+                </a:solidFill>
+                <a:latin typeface="Crimson Pro" pitchFamily="34" charset="0"/>
+                <a:ea typeface="Crimson Pro" pitchFamily="34" charset="-122"/>
+                <a:cs typeface="Crimson Pro" pitchFamily="34" charset="-120"/>
+              </a:rPr>
+              <a:t>Virginia</a:t>
+            </a:r>
+            <a:endParaRPr lang="en-US" sz="4800" dirty="0"/>
+          </a:p>
+        </p:txBody>
+      </p:sp>
+      <p:sp>
+        <p:nvSpPr>
+          <p:cNvPr id="6" name="Text 3"/>
+          <p:cNvSpPr txBox="1"/>
+          <p:nvPr/>
+        </p:nvSpPr>
+        <p:spPr>
+          <a:xfrm>
+            <a:off x="731520" y="3657600"/>
+            <a:ext cx="4233672" cy="2194560"/>
+          </a:xfrm>
+          <a:prstGeom prst="rect">
+            <a:avLst/>
+          </a:prstGeom>
+          <a:noFill/>
+          <a:ln/>
+        </p:spPr>
+        <p:txBody>
+          <a:bodyPr wrap="square" lIns="0" tIns="0" rIns="0" bIns="0" rtlCol="0" anchor="t"/>
+          <a:lstStyle/>
+          <a:p>
+            <a:pPr indent="0" marL="0">
+              <a:buNone/>
+            </a:pPr>
+            <a:r>
               <a:rPr lang="en-US" sz="2000" dirty="0">
                 <a:solidFill>
-                  <a:schemeClr val="bg2"/>
+                  <a:schemeClr val="tx1"/>
                 </a:solidFill>
               </a:rPr>
               <a:t>Una reunión de líderes, 100% en inglés y súper técnica.</a:t>
@@ -9178,7 +9547,7 @@
             <a:lvl1pPr>
               <a:defRPr sz="1100">
                 <a:solidFill>
-                  <a:schemeClr val="bg2"/>
+                  <a:schemeClr val="accent5"/>
                 </a:solidFill>
               </a:defRPr>
             </a:lvl1pPr>
@@ -9245,14 +9614,14 @@
               <a:buNone/>
             </a:pPr>
             <a:r>
-              <a:rPr lang="en-US" sz="1600" b="1" spc="300" kern="0" dirty="0">
+              <a:rPr lang="en-US" sz="1500" b="1" spc="300" kern="0" dirty="0">
                 <a:solidFill>
                   <a:schemeClr val="accent1"/>
                 </a:solidFill>
               </a:rPr>
               <a:t>3 · LO VEO TODO EL TIEMPO</a:t>
             </a:r>
-            <a:endParaRPr lang="en-US" sz="1600" dirty="0"/>
+            <a:endParaRPr lang="en-US" sz="1500" dirty="0"/>
           </a:p>
         </p:txBody>
       </p:sp>
@@ -9281,17 +9650,17 @@
               <a:buNone/>
             </a:pPr>
             <a:r>
-              <a:rPr lang="en-US" sz="4600" i="1" dirty="0">
+              <a:rPr lang="en-US" sz="5200" i="1" dirty="0">
                 <a:solidFill>
                   <a:schemeClr val="bg1"/>
                 </a:solidFill>
-                <a:latin typeface="Cambria" pitchFamily="34" charset="0"/>
-                <a:ea typeface="Cambria" pitchFamily="34" charset="-122"/>
-                <a:cs typeface="Cambria" pitchFamily="34" charset="-120"/>
+                <a:latin typeface="Crimson Pro" pitchFamily="34" charset="0"/>
+                <a:ea typeface="Crimson Pro" pitchFamily="34" charset="-122"/>
+                <a:cs typeface="Crimson Pro" pitchFamily="34" charset="-120"/>
               </a:rPr>
               <a:t>“My participation wasn't the best, but it was the first one.”</a:t>
             </a:r>
-            <a:endParaRPr lang="en-US" sz="4600" dirty="0"/>
+            <a:endParaRPr lang="en-US" sz="5200" dirty="0"/>
           </a:p>
         </p:txBody>
       </p:sp>
@@ -9303,7 +9672,7 @@
         </p:nvSpPr>
         <p:spPr>
           <a:xfrm>
-            <a:off x="731520" y="4023360"/>
+            <a:off x="731520" y="3657600"/>
             <a:ext cx="10058400" cy="457200"/>
           </a:xfrm>
           <a:prstGeom prst="rect">
@@ -9320,7 +9689,7 @@
               <a:buNone/>
             </a:pPr>
             <a:r>
-              <a:rPr lang="en-US" sz="2000" b="1" dirty="0">
+              <a:rPr lang="en-US" sz="1900" b="1" dirty="0">
                 <a:solidFill>
                   <a:schemeClr val="bg1"/>
                 </a:solidFill>
@@ -9331,14 +9700,14 @@
               <a:buNone/>
             </a:pPr>
             <a:r>
-              <a:rPr lang="en-US" sz="2000" dirty="0">
+              <a:rPr lang="en-US" sz="1900" dirty="0">
                 <a:solidFill>
                   <a:schemeClr val="bg2"/>
                 </a:solidFill>
               </a:rPr>
               <a:t> · Primera reunión con el equipo global</a:t>
             </a:r>
-            <a:endParaRPr lang="en-US" sz="2000" dirty="0"/>
+            <a:endParaRPr lang="en-US" sz="1900" dirty="0"/>
           </a:p>
         </p:txBody>
       </p:sp>
@@ -9439,14 +9808,14 @@
               <a:buNone/>
             </a:pPr>
             <a:r>
-              <a:rPr lang="en-US" sz="1600" b="1" spc="300" kern="0" dirty="0">
-                <a:solidFill>
-                  <a:schemeClr val="accent1"/>
+              <a:rPr lang="en-US" sz="1500" b="1" spc="300" kern="0" dirty="0">
+                <a:solidFill>
+                  <a:schemeClr val="accent2"/>
                 </a:solidFill>
               </a:rPr>
               <a:t>3 · LO VEO TODO EL TIEMPO</a:t>
             </a:r>
-            <a:endParaRPr lang="en-US" sz="1600" dirty="0"/>
+            <a:endParaRPr lang="en-US" sz="1500" dirty="0"/>
           </a:p>
         </p:txBody>
       </p:sp>
@@ -9473,42 +9842,42 @@
           <a:p>
             <a:pPr indent="0" marL="0">
               <a:lnSpc>
-                <a:spcPct val="105000"/>
+                <a:spcPct val="100000"/>
               </a:lnSpc>
               <a:buNone/>
             </a:pPr>
             <a:r>
-              <a:rPr lang="en-US" sz="5000" b="1" dirty="0">
-                <a:solidFill>
-                  <a:schemeClr val="bg1"/>
-                </a:solidFill>
-                <a:latin typeface="Cambria" pitchFamily="34" charset="0"/>
-                <a:ea typeface="Cambria" pitchFamily="34" charset="-122"/>
-                <a:cs typeface="Cambria" pitchFamily="34" charset="-120"/>
+              <a:rPr lang="en-US" sz="5800" b="1" dirty="0">
+                <a:solidFill>
+                  <a:schemeClr val="tx1"/>
+                </a:solidFill>
+                <a:latin typeface="Crimson Pro" pitchFamily="34" charset="0"/>
+                <a:ea typeface="Crimson Pro" pitchFamily="34" charset="-122"/>
+                <a:cs typeface="Crimson Pro" pitchFamily="34" charset="-120"/>
               </a:rPr>
               <a:t>Primera entrevista en inglés.</a:t>
             </a:r>
-            <a:endParaRPr lang="en-US" sz="5000" dirty="0"/>
+            <a:endParaRPr lang="en-US" sz="5800" dirty="0"/>
           </a:p>
           <a:p>
             <a:pPr indent="0" marL="0">
               <a:lnSpc>
-                <a:spcPct val="105000"/>
+                <a:spcPct val="100000"/>
               </a:lnSpc>
               <a:buNone/>
             </a:pPr>
             <a:r>
-              <a:rPr lang="en-US" sz="5000" b="1" dirty="0">
-                <a:solidFill>
-                  <a:schemeClr val="accent1"/>
-                </a:solidFill>
-                <a:latin typeface="Cambria" pitchFamily="34" charset="0"/>
-                <a:ea typeface="Cambria" pitchFamily="34" charset="-122"/>
-                <a:cs typeface="Cambria" pitchFamily="34" charset="-120"/>
+              <a:rPr lang="en-US" sz="5800" b="1" i="1" dirty="0">
+                <a:solidFill>
+                  <a:schemeClr val="tx2"/>
+                </a:solidFill>
+                <a:latin typeface="Crimson Pro" pitchFamily="34" charset="0"/>
+                <a:ea typeface="Crimson Pro" pitchFamily="34" charset="-122"/>
+                <a:cs typeface="Crimson Pro" pitchFamily="34" charset="-120"/>
               </a:rPr>
               <a:t>Con Tesla.</a:t>
             </a:r>
-            <a:endParaRPr lang="en-US" sz="5000" dirty="0"/>
+            <a:endParaRPr lang="en-US" sz="5800" dirty="0"/>
           </a:p>
         </p:txBody>
       </p:sp>
@@ -9520,7 +9889,7 @@
         </p:nvSpPr>
         <p:spPr>
           <a:xfrm>
-            <a:off x="731520" y="3657600"/>
+            <a:off x="731520" y="3931920"/>
             <a:ext cx="10058400" cy="914400"/>
           </a:xfrm>
           <a:prstGeom prst="rect">
@@ -9537,14 +9906,14 @@
               <a:buNone/>
             </a:pPr>
             <a:r>
-              <a:rPr lang="en-US" sz="2200" dirty="0">
-                <a:solidFill>
-                  <a:schemeClr val="bg2"/>
+              <a:rPr lang="en-US" sz="2000" dirty="0">
+                <a:solidFill>
+                  <a:schemeClr val="accent5"/>
                 </a:solidFill>
               </a:rPr>
               <a:t>Pudo dar su punto de vista sintiéndose cómoda y segura.</a:t>
             </a:r>
-            <a:endParaRPr lang="en-US" sz="2200" dirty="0"/>
+            <a:endParaRPr lang="en-US" sz="2000" dirty="0"/>
           </a:p>
         </p:txBody>
       </p:sp>
@@ -9556,7 +9925,7 @@
         </p:nvSpPr>
         <p:spPr>
           <a:xfrm>
-            <a:off x="731520" y="4389120"/>
+            <a:off x="731520" y="4480560"/>
             <a:ext cx="10058400" cy="457200"/>
           </a:xfrm>
           <a:prstGeom prst="rect">
@@ -9573,9 +9942,9 @@
               <a:buNone/>
             </a:pPr>
             <a:r>
-              <a:rPr lang="en-US" sz="2000" b="1" dirty="0">
-                <a:solidFill>
-                  <a:schemeClr val="bg1"/>
+              <a:rPr lang="en-US" sz="1900" b="1" dirty="0">
+                <a:solidFill>
+                  <a:schemeClr val="tx1"/>
                 </a:solidFill>
               </a:rPr>
               <a:t>Moni</a:t>
@@ -9584,14 +9953,14 @@
               <a:buNone/>
             </a:pPr>
             <a:r>
-              <a:rPr lang="en-US" sz="2000" dirty="0">
-                <a:solidFill>
-                  <a:schemeClr val="bg2"/>
+              <a:rPr lang="en-US" sz="1900" dirty="0">
+                <a:solidFill>
+                  <a:schemeClr val="accent5"/>
                 </a:solidFill>
               </a:rPr>
               <a:t> · Recursos Humanos</a:t>
             </a:r>
-            <a:endParaRPr lang="en-US" sz="2000" dirty="0"/>
+            <a:endParaRPr lang="en-US" sz="1900" dirty="0"/>
           </a:p>
         </p:txBody>
       </p:sp>
@@ -9625,7 +9994,7 @@
             <a:lvl1pPr>
               <a:defRPr sz="1100">
                 <a:solidFill>
-                  <a:schemeClr val="bg2"/>
+                  <a:schemeClr val="accent5"/>
                 </a:solidFill>
               </a:defRPr>
             </a:lvl1pPr>
@@ -9692,20 +10061,47 @@
               <a:buNone/>
             </a:pPr>
             <a:r>
-              <a:rPr lang="en-US" sz="1600" b="1" spc="300" kern="0" dirty="0">
-                <a:solidFill>
-                  <a:schemeClr val="accent1"/>
+              <a:rPr lang="en-US" sz="1500" b="1" spc="300" kern="0" dirty="0">
+                <a:solidFill>
+                  <a:schemeClr val="accent2"/>
                 </a:solidFill>
               </a:rPr>
               <a:t>3 · LO VEO TODO EL TIEMPO</a:t>
             </a:r>
-            <a:endParaRPr lang="en-US" sz="1600" dirty="0"/>
-          </a:p>
-        </p:txBody>
+            <a:endParaRPr lang="en-US" sz="1500" dirty="0"/>
+          </a:p>
+        </p:txBody>
+      </p:sp>
+      <p:sp>
+        <p:nvSpPr>
+          <p:cNvPr id="3" name="marco"/>
+          <p:cNvSpPr/>
+          <p:nvPr/>
+        </p:nvSpPr>
+        <p:spPr>
+          <a:xfrm>
+            <a:off x="6454745" y="1572768"/>
+            <a:ext cx="5167279" cy="4901184"/>
+          </a:xfrm>
+          <a:prstGeom prst="roundRect">
+            <a:avLst>
+              <a:gd name="adj" fmla="val 3731"/>
+            </a:avLst>
+          </a:prstGeom>
+          <a:solidFill>
+            <a:schemeClr val="bg2"/>
+          </a:solidFill>
+          <a:ln w="12700">
+            <a:solidFill>
+              <a:schemeClr val="accent2"/>
+            </a:solidFill>
+            <a:prstDash val="solid"/>
+          </a:ln>
+        </p:spPr>
       </p:sp>
       <p:pic>
         <p:nvPicPr>
-          <p:cNvPr id="3" name="captura" descr="Captura del mensaje de Sol en la comunidad">    </p:cNvPr>
+          <p:cNvPr id="4" name="captura" descr="Captura del mensaje de Sol en la comunidad">    </p:cNvPr>
           <p:cNvPicPr>
             <a:picLocks noChangeAspect="1"/>
           </p:cNvPicPr>
@@ -9729,53 +10125,14 @@
       </p:pic>
       <p:sp>
         <p:nvSpPr>
-          <p:cNvPr id="4" name="Text 1"/>
-          <p:cNvSpPr txBox="1"/>
-          <p:nvPr/>
-        </p:nvSpPr>
-        <p:spPr>
-          <a:xfrm>
-            <a:off x="731520" y="2194560"/>
-            <a:ext cx="5339177" cy="914400"/>
-          </a:xfrm>
-          <a:prstGeom prst="rect">
-            <a:avLst/>
-          </a:prstGeom>
-          <a:noFill/>
-          <a:ln/>
-        </p:spPr>
-        <p:txBody>
-          <a:bodyPr wrap="square" lIns="0" tIns="0" rIns="0" bIns="0" rtlCol="0" anchor="t"/>
-          <a:lstStyle/>
-          <a:p>
-            <a:pPr indent="0" marL="0">
-              <a:buNone/>
-            </a:pPr>
-            <a:r>
-              <a:rPr lang="en-US" sz="4000" b="1" dirty="0">
-                <a:solidFill>
-                  <a:schemeClr val="bg1"/>
-                </a:solidFill>
-                <a:latin typeface="Cambria" pitchFamily="34" charset="0"/>
-                <a:ea typeface="Cambria" pitchFamily="34" charset="-122"/>
-                <a:cs typeface="Cambria" pitchFamily="34" charset="-120"/>
-              </a:rPr>
-              <a:t>Sol</a:t>
-            </a:r>
-            <a:endParaRPr lang="en-US" sz="4000" dirty="0"/>
-          </a:p>
-        </p:txBody>
-      </p:sp>
-      <p:sp>
-        <p:nvSpPr>
           <p:cNvPr id="5" name="Text 2"/>
           <p:cNvSpPr txBox="1"/>
           <p:nvPr/>
         </p:nvSpPr>
         <p:spPr>
           <a:xfrm>
-            <a:off x="731520" y="3200400"/>
-            <a:ext cx="5339177" cy="2011680"/>
+            <a:off x="731520" y="2103120"/>
+            <a:ext cx="5247737" cy="1463040"/>
           </a:xfrm>
           <a:prstGeom prst="rect">
             <a:avLst/>
@@ -9791,9 +10148,48 @@
               <a:buNone/>
             </a:pPr>
             <a:r>
+              <a:rPr lang="en-US" sz="4800" b="1" dirty="0">
+                <a:solidFill>
+                  <a:schemeClr val="tx2"/>
+                </a:solidFill>
+                <a:latin typeface="Crimson Pro" pitchFamily="34" charset="0"/>
+                <a:ea typeface="Crimson Pro" pitchFamily="34" charset="-122"/>
+                <a:cs typeface="Crimson Pro" pitchFamily="34" charset="-120"/>
+              </a:rPr>
+              <a:t>Sol</a:t>
+            </a:r>
+            <a:endParaRPr lang="en-US" sz="4800" dirty="0"/>
+          </a:p>
+        </p:txBody>
+      </p:sp>
+      <p:sp>
+        <p:nvSpPr>
+          <p:cNvPr id="6" name="Text 3"/>
+          <p:cNvSpPr txBox="1"/>
+          <p:nvPr/>
+        </p:nvSpPr>
+        <p:spPr>
+          <a:xfrm>
+            <a:off x="731520" y="3657600"/>
+            <a:ext cx="5247737" cy="2194560"/>
+          </a:xfrm>
+          <a:prstGeom prst="rect">
+            <a:avLst/>
+          </a:prstGeom>
+          <a:noFill/>
+          <a:ln/>
+        </p:spPr>
+        <p:txBody>
+          <a:bodyPr wrap="square" lIns="0" tIns="0" rIns="0" bIns="0" rtlCol="0" anchor="t"/>
+          <a:lstStyle/>
+          <a:p>
+            <a:pPr indent="0" marL="0">
+              <a:buNone/>
+            </a:pPr>
+            <a:r>
               <a:rPr lang="en-US" sz="2000" dirty="0">
                 <a:solidFill>
-                  <a:schemeClr val="bg2"/>
+                  <a:schemeClr val="tx1"/>
                 </a:solidFill>
               </a:rPr>
               <a:t>Gerenta de logística. Viaje de trabajo a Alemania: “this time I can see significant progress in myself”.</a:t>
@@ -9832,7 +10228,7 @@
             <a:lvl1pPr>
               <a:defRPr sz="1100">
                 <a:solidFill>
-                  <a:schemeClr val="bg2"/>
+                  <a:schemeClr val="accent5"/>
                 </a:solidFill>
               </a:defRPr>
             </a:lvl1pPr>
@@ -9856,49 +10252,49 @@
 </file>
 
 <file path=ppt/theme/theme1.xml><?xml version="1.0" encoding="utf-8"?>
-<a:theme xmlns:a="http://schemas.openxmlformats.org/drawingml/2006/main" name="Breaking Barriers AT WORK">
+<a:theme xmlns:a="http://schemas.openxmlformats.org/drawingml/2006/main" name="Flor Pérsico · Breaking Barriers">
   <a:themeElements>
-    <a:clrScheme name="Breaking Barriers AT WORK">
+    <a:clrScheme name="Flor Pérsico · Breaking Barriers">
       <a:dk1>
-        <a:srgbClr val="1C1A19"/>
+        <a:srgbClr val="2C1F0E"/>
       </a:dk1>
       <a:lt1>
-        <a:srgbClr val="F3EADB"/>
+        <a:srgbClr val="FFF8E7"/>
       </a:lt1>
       <a:dk2>
-        <a:srgbClr val="262321"/>
+        <a:srgbClr val="82552E"/>
       </a:dk2>
       <a:lt2>
-        <a:srgbClr val="BDB3A3"/>
+        <a:srgbClr val="F5EDD6"/>
       </a:lt2>
       <a:accent1>
-        <a:srgbClr val="D9A46B"/>
+        <a:srgbClr val="E8C4AD"/>
       </a:accent1>
       <a:accent2>
-        <a:srgbClr val="8C6A48"/>
+        <a:srgbClr val="C68C6C"/>
       </a:accent2>
       <a:accent3>
-        <a:srgbClr val="3A3531"/>
+        <a:srgbClr val="6E4624"/>
       </a:accent3>
       <a:accent4>
-        <a:srgbClr val="F3EADB"/>
+        <a:srgbClr val="5C3D1E"/>
       </a:accent4>
       <a:accent5>
-        <a:srgbClr val="BDB3A3"/>
+        <a:srgbClr val="8B6B4A"/>
       </a:accent5>
       <a:accent6>
-        <a:srgbClr val="D9A46B"/>
+        <a:srgbClr val="6B6F4C"/>
       </a:accent6>
       <a:hlink>
-        <a:srgbClr val="D9A46B"/>
+        <a:srgbClr val="C68C6C"/>
       </a:hlink>
       <a:folHlink>
-        <a:srgbClr val="BDB3A3"/>
+        <a:srgbClr val="8B6B4A"/>
       </a:folHlink>
     </a:clrScheme>
-    <a:fontScheme name="Breaking Barriers AT WORK">
+    <a:fontScheme name="Flor Pérsico · Breaking Barriers">
       <a:majorFont>
-        <a:latin typeface="Cambria"/>
+        <a:latin typeface="Crimson Pro"/>
         <a:ea typeface=""/>
         <a:cs typeface=""/>
         <a:font script="Jpan" typeface="游ゴシック Light"/>
@@ -9950,7 +10346,7 @@
         <a:font script="Tfng" typeface="Ebrima"/>
       </a:majorFont>
       <a:minorFont>
-        <a:latin typeface="Calibri"/>
+        <a:latin typeface="Open Sans"/>
         <a:ea typeface=""/>
         <a:cs typeface=""/>
         <a:font script="Jpan" typeface="游ゴシック"/>

</xml_diff>